<commit_message>
Mise a joue de centre envoyer
</commit_message>
<xml_diff>
--- a/NIJAC.pptx
+++ b/NIJAC.pptx
@@ -8,20 +8,24 @@
     <p:sldId id="256" r:id="rId2"/>
     <p:sldId id="257" r:id="rId3"/>
     <p:sldId id="258" r:id="rId4"/>
-    <p:sldId id="259" r:id="rId5"/>
-    <p:sldId id="269" r:id="rId6"/>
-    <p:sldId id="270" r:id="rId7"/>
-    <p:sldId id="260" r:id="rId8"/>
-    <p:sldId id="271" r:id="rId9"/>
-    <p:sldId id="272" r:id="rId10"/>
-    <p:sldId id="261" r:id="rId11"/>
-    <p:sldId id="262" r:id="rId12"/>
-    <p:sldId id="263" r:id="rId13"/>
-    <p:sldId id="268" r:id="rId14"/>
-    <p:sldId id="264" r:id="rId15"/>
-    <p:sldId id="265" r:id="rId16"/>
-    <p:sldId id="266" r:id="rId17"/>
-    <p:sldId id="267" r:id="rId18"/>
+    <p:sldId id="273" r:id="rId5"/>
+    <p:sldId id="274" r:id="rId6"/>
+    <p:sldId id="259" r:id="rId7"/>
+    <p:sldId id="269" r:id="rId8"/>
+    <p:sldId id="270" r:id="rId9"/>
+    <p:sldId id="260" r:id="rId10"/>
+    <p:sldId id="271" r:id="rId11"/>
+    <p:sldId id="272" r:id="rId12"/>
+    <p:sldId id="275" r:id="rId13"/>
+    <p:sldId id="276" r:id="rId14"/>
+    <p:sldId id="261" r:id="rId15"/>
+    <p:sldId id="262" r:id="rId16"/>
+    <p:sldId id="263" r:id="rId17"/>
+    <p:sldId id="268" r:id="rId18"/>
+    <p:sldId id="264" r:id="rId19"/>
+    <p:sldId id="265" r:id="rId20"/>
+    <p:sldId id="266" r:id="rId21"/>
+    <p:sldId id="267" r:id="rId22"/>
   </p:sldIdLst>
   <p:sldSz cx="12192000" cy="6858000"/>
   <p:notesSz cx="6858000" cy="9144000"/>
@@ -120,6 +124,11 @@
       </a:defRPr>
     </a:lvl9pPr>
   </p:defaultTextStyle>
+  <p:extLst>
+    <p:ext uri="{EFAFB233-063F-42B5-8137-9DF3F51BA10A}">
+      <p15:sldGuideLst xmlns:p15="http://schemas.microsoft.com/office/powerpoint/2012/main"/>
+    </p:ext>
+  </p:extLst>
 </p:presentation>
 </file>
 
@@ -397,7 +406,7 @@
           <a:p>
             <a:fld id="{78ABE3C1-DBE1-495D-B57B-2849774B866A}" type="datetimeFigureOut">
               <a:rPr lang="en-US" dirty="0"/>
-              <a:t>7/10/2026</a:t>
+              <a:t>7/26/2026</a:t>
             </a:fld>
             <a:endParaRPr lang="en-US" dirty="0"/>
           </a:p>
@@ -806,7 +815,7 @@
           <a:p>
             <a:fld id="{446C117F-5CCF-4837-BE5F-2B92066CAFAF}" type="datetimeFigureOut">
               <a:rPr lang="en-US" dirty="0"/>
-              <a:t>7/10/2026</a:t>
+              <a:t>7/26/2026</a:t>
             </a:fld>
             <a:endParaRPr lang="en-US" dirty="0"/>
           </a:p>
@@ -1137,7 +1146,7 @@
           <a:p>
             <a:fld id="{84EB90BD-B6CE-46B7-997F-7313B992CCDC}" type="datetimeFigureOut">
               <a:rPr lang="en-US" dirty="0"/>
-              <a:t>7/10/2026</a:t>
+              <a:t>7/26/2026</a:t>
             </a:fld>
             <a:endParaRPr lang="en-US" dirty="0"/>
           </a:p>
@@ -1537,7 +1546,7 @@
           <a:p>
             <a:fld id="{CDB9D11F-B188-461D-B23F-39381795C052}" type="datetimeFigureOut">
               <a:rPr lang="en-US" dirty="0"/>
-              <a:t>7/10/2026</a:t>
+              <a:t>7/26/2026</a:t>
             </a:fld>
             <a:endParaRPr lang="en-US" dirty="0"/>
           </a:p>
@@ -2100,7 +2109,7 @@
           <a:p>
             <a:fld id="{52E6D8D9-55A2-4063-B0F3-121F44549695}" type="datetimeFigureOut">
               <a:rPr lang="en-US" dirty="0"/>
-              <a:t>7/10/2026</a:t>
+              <a:t>7/26/2026</a:t>
             </a:fld>
             <a:endParaRPr lang="en-US" dirty="0"/>
           </a:p>
@@ -2776,7 +2785,7 @@
           <a:p>
             <a:fld id="{D4B24536-994D-4021-A283-9F449C0DB509}" type="datetimeFigureOut">
               <a:rPr lang="en-US" dirty="0"/>
-              <a:t>7/10/2026</a:t>
+              <a:t>7/26/2026</a:t>
             </a:fld>
             <a:endParaRPr lang="en-US" dirty="0"/>
           </a:p>
@@ -3684,7 +3693,7 @@
           <a:p>
             <a:fld id="{3CBBBB78-C96F-47B7-AB17-D852CA960AC9}" type="datetimeFigureOut">
               <a:rPr lang="en-US" dirty="0"/>
-              <a:t>7/10/2026</a:t>
+              <a:t>7/26/2026</a:t>
             </a:fld>
             <a:endParaRPr lang="en-US" dirty="0"/>
           </a:p>
@@ -3992,7 +4001,7 @@
           <a:p>
             <a:fld id="{1FA3F48C-C7C6-4055-9F49-3777875E72AE}" type="datetimeFigureOut">
               <a:rPr lang="en-US" dirty="0"/>
-              <a:t>7/10/2026</a:t>
+              <a:t>7/26/2026</a:t>
             </a:fld>
             <a:endParaRPr lang="en-US" dirty="0"/>
           </a:p>
@@ -4251,7 +4260,7 @@
           <a:p>
             <a:fld id="{6178E61D-D431-422C-9764-11DAFE33AB63}" type="datetimeFigureOut">
               <a:rPr lang="en-US" dirty="0"/>
-              <a:t>7/10/2026</a:t>
+              <a:t>7/26/2026</a:t>
             </a:fld>
             <a:endParaRPr lang="en-US" dirty="0"/>
           </a:p>
@@ -4570,7 +4579,7 @@
           <a:p>
             <a:fld id="{12DE42F4-6EEF-4EF7-8ED4-2208F0F89A08}" type="datetimeFigureOut">
               <a:rPr lang="en-US" dirty="0"/>
-              <a:t>7/10/2026</a:t>
+              <a:t>7/26/2026</a:t>
             </a:fld>
             <a:endParaRPr lang="en-US" dirty="0"/>
           </a:p>
@@ -4954,7 +4963,7 @@
           <a:p>
             <a:fld id="{30578ACC-22D6-47C1-A373-4FD133E34F3C}" type="datetimeFigureOut">
               <a:rPr lang="en-US" dirty="0"/>
-              <a:t>7/10/2026</a:t>
+              <a:t>7/26/2026</a:t>
             </a:fld>
             <a:endParaRPr lang="en-US" dirty="0"/>
           </a:p>
@@ -5325,7 +5334,7 @@
           <a:p>
             <a:fld id="{4E5A6C69-6797-4E8A-BF37-F2C3751466E9}" type="datetimeFigureOut">
               <a:rPr lang="en-US" dirty="0"/>
-              <a:t>7/10/2026</a:t>
+              <a:t>7/26/2026</a:t>
             </a:fld>
             <a:endParaRPr lang="en-US" dirty="0"/>
           </a:p>
@@ -5826,7 +5835,7 @@
           <a:p>
             <a:fld id="{D82014A1-A632-4878-A0D3-F52BA7563730}" type="datetimeFigureOut">
               <a:rPr lang="en-US" dirty="0"/>
-              <a:t>7/10/2026</a:t>
+              <a:t>7/26/2026</a:t>
             </a:fld>
             <a:endParaRPr lang="en-US" dirty="0"/>
           </a:p>
@@ -6078,7 +6087,7 @@
           <a:p>
             <a:fld id="{CE99F462-093F-4566-844B-4C71F2739DA5}" type="datetimeFigureOut">
               <a:rPr lang="en-US" dirty="0"/>
-              <a:t>7/10/2026</a:t>
+              <a:t>7/26/2026</a:t>
             </a:fld>
             <a:endParaRPr lang="en-US" dirty="0"/>
           </a:p>
@@ -6236,7 +6245,7 @@
           <a:p>
             <a:fld id="{3D24A7AC-904D-4781-85BA-7D10C17ED021}" type="datetimeFigureOut">
               <a:rPr lang="en-US" dirty="0"/>
-              <a:t>7/10/2026</a:t>
+              <a:t>7/26/2026</a:t>
             </a:fld>
             <a:endParaRPr lang="en-US" dirty="0"/>
           </a:p>
@@ -6621,7 +6630,7 @@
           <a:p>
             <a:fld id="{E331444B-B92B-4E27-8C94-BB93EAF5CB18}" type="datetimeFigureOut">
               <a:rPr lang="en-US" dirty="0"/>
-              <a:t>7/10/2026</a:t>
+              <a:t>7/26/2026</a:t>
             </a:fld>
             <a:endParaRPr lang="en-US" dirty="0"/>
           </a:p>
@@ -7025,7 +7034,7 @@
           <a:p>
             <a:fld id="{363EFA5E-FA76-400D-B3DC-F0BA90E6D107}" type="datetimeFigureOut">
               <a:rPr lang="en-US" dirty="0"/>
-              <a:t>7/10/2026</a:t>
+              <a:t>7/26/2026</a:t>
             </a:fld>
             <a:endParaRPr lang="en-US" dirty="0"/>
           </a:p>
@@ -7264,7 +7273,7 @@
           <a:p>
             <a:fld id="{9D6E9DEC-419B-4CC5-A080-3B06BD5A8291}" type="datetimeFigureOut">
               <a:rPr lang="en-US" dirty="0"/>
-              <a:t>7/10/2026</a:t>
+              <a:t>7/26/2026</a:t>
             </a:fld>
             <a:endParaRPr lang="en-US" dirty="0"/>
           </a:p>
@@ -7725,13 +7734,8 @@
             <a:pPr algn="ctr"/>
             <a:r>
               <a:rPr lang="fr-FR" dirty="0"/>
-              <a:t>Nomination Informatisé des Juge Arbitre pour les </a:t>
-            </a:r>
-            <a:r>
-              <a:rPr lang="fr-FR" dirty="0" err="1"/>
-              <a:t>Championats</a:t>
-            </a:r>
-            <a:endParaRPr lang="fr-FR" dirty="0"/>
+              <a:t>Nomination Informatisé des Juge Arbitre pour les Championnats</a:t>
+            </a:r>
           </a:p>
         </p:txBody>
       </p:sp>
@@ -7770,7 +7774,7 @@
           <p:cNvPr id="2" name="Titre 1">
             <a:extLst>
               <a:ext uri="{FF2B5EF4-FFF2-40B4-BE49-F238E27FC236}">
-                <a16:creationId xmlns:a16="http://schemas.microsoft.com/office/drawing/2014/main" id="{64CA944C-650E-872F-CDEB-F23DCF579310}"/>
+                <a16:creationId xmlns:a16="http://schemas.microsoft.com/office/drawing/2014/main" id="{F2D4B57F-2449-8012-12CC-ACCF428271E2}"/>
               </a:ext>
             </a:extLst>
           </p:cNvPr>
@@ -7788,17 +7792,17 @@
           <a:p>
             <a:r>
               <a:rPr lang="fr-FR" dirty="0"/>
-              <a:t>Désidératas Clubs</a:t>
+              <a:t>Disponibilités JA</a:t>
             </a:r>
           </a:p>
         </p:txBody>
       </p:sp>
       <p:pic>
         <p:nvPicPr>
-          <p:cNvPr id="4098" name="Picture 2" descr="Import Rencontres">
+          <p:cNvPr id="3074" name="Picture 2" descr="Disponibilités JA">
             <a:extLst>
               <a:ext uri="{FF2B5EF4-FFF2-40B4-BE49-F238E27FC236}">
-                <a16:creationId xmlns:a16="http://schemas.microsoft.com/office/drawing/2014/main" id="{6684EB83-F2ED-DCD1-2718-087B4E0437E0}"/>
+                <a16:creationId xmlns:a16="http://schemas.microsoft.com/office/drawing/2014/main" id="{11909562-16B8-3838-F899-1B87CA15D58F}"/>
               </a:ext>
             </a:extLst>
           </p:cNvPr>
@@ -7822,8 +7826,8 @@
         </p:blipFill>
         <p:spPr bwMode="auto">
           <a:xfrm>
-            <a:off x="10780725" y="689644"/>
-            <a:ext cx="1287623" cy="1030098"/>
+            <a:off x="10893760" y="753228"/>
+            <a:ext cx="1092010" cy="1138420"/>
           </a:xfrm>
           <a:prstGeom prst="rect">
             <a:avLst/>
@@ -7842,10 +7846,10 @@
       </p:pic>
       <p:pic>
         <p:nvPicPr>
-          <p:cNvPr id="5" name="Image 4">
+          <p:cNvPr id="4" name="Image 3">
             <a:extLst>
               <a:ext uri="{FF2B5EF4-FFF2-40B4-BE49-F238E27FC236}">
-                <a16:creationId xmlns:a16="http://schemas.microsoft.com/office/drawing/2014/main" id="{54F2B0D0-8A20-BBCD-DF0A-EE2EE0DE6BF5}"/>
+                <a16:creationId xmlns:a16="http://schemas.microsoft.com/office/drawing/2014/main" id="{7AB49EDF-1A92-E9B3-5985-87F0426F05F4}"/>
               </a:ext>
             </a:extLst>
           </p:cNvPr>
@@ -7862,8 +7866,68 @@
         </p:blipFill>
         <p:spPr>
           <a:xfrm>
-            <a:off x="1234911" y="2130631"/>
-            <a:ext cx="9545814" cy="4588951"/>
+            <a:off x="409223" y="2128956"/>
+            <a:ext cx="3760105" cy="3890044"/>
+          </a:xfrm>
+          <a:prstGeom prst="rect">
+            <a:avLst/>
+          </a:prstGeom>
+        </p:spPr>
+      </p:pic>
+      <p:pic>
+        <p:nvPicPr>
+          <p:cNvPr id="7" name="Image 6">
+            <a:extLst>
+              <a:ext uri="{FF2B5EF4-FFF2-40B4-BE49-F238E27FC236}">
+                <a16:creationId xmlns:a16="http://schemas.microsoft.com/office/drawing/2014/main" id="{22B64E45-33C1-2F45-A07D-746A0916CFE0}"/>
+              </a:ext>
+            </a:extLst>
+          </p:cNvPr>
+          <p:cNvPicPr>
+            <a:picLocks noChangeAspect="1"/>
+          </p:cNvPicPr>
+          <p:nvPr/>
+        </p:nvPicPr>
+        <p:blipFill>
+          <a:blip r:embed="rId4"/>
+          <a:stretch>
+            <a:fillRect/>
+          </a:stretch>
+        </p:blipFill>
+        <p:spPr>
+          <a:xfrm>
+            <a:off x="4908416" y="2304739"/>
+            <a:ext cx="6947277" cy="656575"/>
+          </a:xfrm>
+          <a:prstGeom prst="rect">
+            <a:avLst/>
+          </a:prstGeom>
+        </p:spPr>
+      </p:pic>
+      <p:pic>
+        <p:nvPicPr>
+          <p:cNvPr id="9" name="Image 8">
+            <a:extLst>
+              <a:ext uri="{FF2B5EF4-FFF2-40B4-BE49-F238E27FC236}">
+                <a16:creationId xmlns:a16="http://schemas.microsoft.com/office/drawing/2014/main" id="{74C3AE98-DC02-699A-355E-553CEB0E1D6F}"/>
+              </a:ext>
+            </a:extLst>
+          </p:cNvPr>
+          <p:cNvPicPr>
+            <a:picLocks noChangeAspect="1"/>
+          </p:cNvPicPr>
+          <p:nvPr/>
+        </p:nvPicPr>
+        <p:blipFill>
+          <a:blip r:embed="rId5"/>
+          <a:stretch>
+            <a:fillRect/>
+          </a:stretch>
+        </p:blipFill>
+        <p:spPr>
+          <a:xfrm>
+            <a:off x="7615563" y="3244133"/>
+            <a:ext cx="2229161" cy="1305107"/>
           </a:xfrm>
           <a:prstGeom prst="rect">
             <a:avLst/>
@@ -7873,7 +7937,7 @@
     </p:spTree>
     <p:extLst>
       <p:ext uri="{BB962C8B-B14F-4D97-AF65-F5344CB8AC3E}">
-        <p14:creationId xmlns:p14="http://schemas.microsoft.com/office/powerpoint/2010/main" val="2279569518"/>
+        <p14:creationId xmlns:p14="http://schemas.microsoft.com/office/powerpoint/2010/main" val="2361119301"/>
       </p:ext>
     </p:extLst>
   </p:cSld>
@@ -7905,7 +7969,7 @@
           <p:cNvPr id="2" name="Titre 1">
             <a:extLst>
               <a:ext uri="{FF2B5EF4-FFF2-40B4-BE49-F238E27FC236}">
-                <a16:creationId xmlns:a16="http://schemas.microsoft.com/office/drawing/2014/main" id="{5468EA9C-CF84-3767-6023-E77D3947CC9C}"/>
+                <a16:creationId xmlns:a16="http://schemas.microsoft.com/office/drawing/2014/main" id="{F2D4B57F-2449-8012-12CC-ACCF428271E2}"/>
               </a:ext>
             </a:extLst>
           </p:cNvPr>
@@ -7923,26 +7987,24 @@
           <a:p>
             <a:r>
               <a:rPr lang="fr-FR" dirty="0"/>
-              <a:t>Nomination JA</a:t>
+              <a:t>Disponibilités JA</a:t>
             </a:r>
           </a:p>
         </p:txBody>
       </p:sp>
       <p:pic>
         <p:nvPicPr>
-          <p:cNvPr id="5122" name="Picture 2" descr="Nomination JA">
+          <p:cNvPr id="3074" name="Picture 2" descr="Disponibilités JA">
             <a:extLst>
               <a:ext uri="{FF2B5EF4-FFF2-40B4-BE49-F238E27FC236}">
-                <a16:creationId xmlns:a16="http://schemas.microsoft.com/office/drawing/2014/main" id="{76066D18-0978-CA5D-7AD1-C2189B58B62B}"/>
+                <a16:creationId xmlns:a16="http://schemas.microsoft.com/office/drawing/2014/main" id="{11909562-16B8-3838-F899-1B87CA15D58F}"/>
               </a:ext>
             </a:extLst>
           </p:cNvPr>
           <p:cNvPicPr>
-            <a:picLocks noGrp="1" noChangeAspect="1" noChangeArrowheads="1"/>
+            <a:picLocks noChangeAspect="1" noChangeArrowheads="1"/>
           </p:cNvPicPr>
-          <p:nvPr>
-            <p:ph idx="1"/>
-          </p:nvPr>
+          <p:nvPr/>
         </p:nvPicPr>
         <p:blipFill>
           <a:blip r:embed="rId2">
@@ -7958,9 +8020,9 @@
           </a:stretch>
         </p:blipFill>
         <p:spPr bwMode="auto">
-          <a:xfrm flipH="1">
-            <a:off x="10676289" y="860187"/>
-            <a:ext cx="1408444" cy="792443"/>
+          <a:xfrm>
+            <a:off x="10893760" y="753228"/>
+            <a:ext cx="1092010" cy="1138420"/>
           </a:xfrm>
           <a:prstGeom prst="rect">
             <a:avLst/>
@@ -7982,7 +8044,7 @@
           <p:cNvPr id="5" name="Image 4">
             <a:extLst>
               <a:ext uri="{FF2B5EF4-FFF2-40B4-BE49-F238E27FC236}">
-                <a16:creationId xmlns:a16="http://schemas.microsoft.com/office/drawing/2014/main" id="{423F93F1-C8F4-9A60-2258-88061CCD6CA7}"/>
+                <a16:creationId xmlns:a16="http://schemas.microsoft.com/office/drawing/2014/main" id="{1BF79E6E-C26C-856A-4F2E-84E6F6902643}"/>
               </a:ext>
             </a:extLst>
           </p:cNvPr>
@@ -7999,8 +8061,8 @@
         </p:blipFill>
         <p:spPr>
           <a:xfrm>
-            <a:off x="1427036" y="2067973"/>
-            <a:ext cx="9648250" cy="4643220"/>
+            <a:off x="973123" y="1739330"/>
+            <a:ext cx="10354800" cy="4988641"/>
           </a:xfrm>
           <a:prstGeom prst="rect">
             <a:avLst/>
@@ -8010,7 +8072,7 @@
     </p:spTree>
     <p:extLst>
       <p:ext uri="{BB962C8B-B14F-4D97-AF65-F5344CB8AC3E}">
-        <p14:creationId xmlns:p14="http://schemas.microsoft.com/office/powerpoint/2010/main" val="3299174755"/>
+        <p14:creationId xmlns:p14="http://schemas.microsoft.com/office/powerpoint/2010/main" val="1178459475"/>
       </p:ext>
     </p:extLst>
   </p:cSld>
@@ -8042,7 +8104,7 @@
           <p:cNvPr id="2" name="Titre 1">
             <a:extLst>
               <a:ext uri="{FF2B5EF4-FFF2-40B4-BE49-F238E27FC236}">
-                <a16:creationId xmlns:a16="http://schemas.microsoft.com/office/drawing/2014/main" id="{DFDBCE47-2A87-B2E4-868B-7C71124D4995}"/>
+                <a16:creationId xmlns:a16="http://schemas.microsoft.com/office/drawing/2014/main" id="{F2D4B57F-2449-8012-12CC-ACCF428271E2}"/>
               </a:ext>
             </a:extLst>
           </p:cNvPr>
@@ -8060,26 +8122,24 @@
           <a:p>
             <a:r>
               <a:rPr lang="fr-FR" dirty="0"/>
-              <a:t>Messagerie</a:t>
+              <a:t>Disponibilités JA</a:t>
             </a:r>
           </a:p>
         </p:txBody>
       </p:sp>
       <p:pic>
         <p:nvPicPr>
-          <p:cNvPr id="6146" name="Picture 2" descr="Messagerie">
+          <p:cNvPr id="3074" name="Picture 2" descr="Disponibilités JA">
             <a:extLst>
               <a:ext uri="{FF2B5EF4-FFF2-40B4-BE49-F238E27FC236}">
-                <a16:creationId xmlns:a16="http://schemas.microsoft.com/office/drawing/2014/main" id="{5D3D5C73-B4C3-CB83-BB3F-0641FD899940}"/>
+                <a16:creationId xmlns:a16="http://schemas.microsoft.com/office/drawing/2014/main" id="{11909562-16B8-3838-F899-1B87CA15D58F}"/>
               </a:ext>
             </a:extLst>
           </p:cNvPr>
           <p:cNvPicPr>
-            <a:picLocks noGrp="1" noChangeAspect="1" noChangeArrowheads="1"/>
+            <a:picLocks noChangeAspect="1" noChangeArrowheads="1"/>
           </p:cNvPicPr>
-          <p:nvPr>
-            <p:ph idx="1"/>
-          </p:nvPr>
+          <p:nvPr/>
         </p:nvPicPr>
         <p:blipFill>
           <a:blip r:embed="rId2">
@@ -8096,8 +8156,8 @@
         </p:blipFill>
         <p:spPr bwMode="auto">
           <a:xfrm>
-            <a:off x="10912056" y="753228"/>
-            <a:ext cx="1080938" cy="1080938"/>
+            <a:off x="10893760" y="753228"/>
+            <a:ext cx="1092010" cy="1138420"/>
           </a:xfrm>
           <a:prstGeom prst="rect">
             <a:avLst/>
@@ -8116,10 +8176,10 @@
       </p:pic>
       <p:pic>
         <p:nvPicPr>
-          <p:cNvPr id="5" name="Image 4">
+          <p:cNvPr id="4" name="Image 3">
             <a:extLst>
               <a:ext uri="{FF2B5EF4-FFF2-40B4-BE49-F238E27FC236}">
-                <a16:creationId xmlns:a16="http://schemas.microsoft.com/office/drawing/2014/main" id="{F939DCA9-5C8A-3BB1-2598-F34F521950A7}"/>
+                <a16:creationId xmlns:a16="http://schemas.microsoft.com/office/drawing/2014/main" id="{56A159CC-BC97-A655-0471-F51244BEABA8}"/>
               </a:ext>
             </a:extLst>
           </p:cNvPr>
@@ -8136,8 +8196,8 @@
         </p:blipFill>
         <p:spPr>
           <a:xfrm>
-            <a:off x="1253675" y="2088263"/>
-            <a:ext cx="9658381" cy="4648096"/>
+            <a:off x="771786" y="1766142"/>
+            <a:ext cx="10403625" cy="5012163"/>
           </a:xfrm>
           <a:prstGeom prst="rect">
             <a:avLst/>
@@ -8147,7 +8207,7 @@
     </p:spTree>
     <p:extLst>
       <p:ext uri="{BB962C8B-B14F-4D97-AF65-F5344CB8AC3E}">
-        <p14:creationId xmlns:p14="http://schemas.microsoft.com/office/powerpoint/2010/main" val="249029771"/>
+        <p14:creationId xmlns:p14="http://schemas.microsoft.com/office/powerpoint/2010/main" val="3201153202"/>
       </p:ext>
     </p:extLst>
   </p:cSld>
@@ -8179,7 +8239,7 @@
           <p:cNvPr id="2" name="Titre 1">
             <a:extLst>
               <a:ext uri="{FF2B5EF4-FFF2-40B4-BE49-F238E27FC236}">
-                <a16:creationId xmlns:a16="http://schemas.microsoft.com/office/drawing/2014/main" id="{DFDBCE47-2A87-B2E4-868B-7C71124D4995}"/>
+                <a16:creationId xmlns:a16="http://schemas.microsoft.com/office/drawing/2014/main" id="{F2D4B57F-2449-8012-12CC-ACCF428271E2}"/>
               </a:ext>
             </a:extLst>
           </p:cNvPr>
@@ -8197,26 +8257,24 @@
           <a:p>
             <a:r>
               <a:rPr lang="fr-FR" dirty="0"/>
-              <a:t>Messagerie</a:t>
+              <a:t>Disponibilités JA</a:t>
             </a:r>
           </a:p>
         </p:txBody>
       </p:sp>
       <p:pic>
         <p:nvPicPr>
-          <p:cNvPr id="6146" name="Picture 2" descr="Messagerie">
+          <p:cNvPr id="3074" name="Picture 2" descr="Disponibilités JA">
             <a:extLst>
               <a:ext uri="{FF2B5EF4-FFF2-40B4-BE49-F238E27FC236}">
-                <a16:creationId xmlns:a16="http://schemas.microsoft.com/office/drawing/2014/main" id="{5D3D5C73-B4C3-CB83-BB3F-0641FD899940}"/>
+                <a16:creationId xmlns:a16="http://schemas.microsoft.com/office/drawing/2014/main" id="{11909562-16B8-3838-F899-1B87CA15D58F}"/>
               </a:ext>
             </a:extLst>
           </p:cNvPr>
           <p:cNvPicPr>
-            <a:picLocks noGrp="1" noChangeAspect="1" noChangeArrowheads="1"/>
+            <a:picLocks noChangeAspect="1" noChangeArrowheads="1"/>
           </p:cNvPicPr>
-          <p:nvPr>
-            <p:ph idx="1"/>
-          </p:nvPr>
+          <p:nvPr/>
         </p:nvPicPr>
         <p:blipFill>
           <a:blip r:embed="rId2">
@@ -8233,8 +8291,8 @@
         </p:blipFill>
         <p:spPr bwMode="auto">
           <a:xfrm>
-            <a:off x="10912056" y="753228"/>
-            <a:ext cx="1080938" cy="1080938"/>
+            <a:off x="10893760" y="753228"/>
+            <a:ext cx="1092010" cy="1138420"/>
           </a:xfrm>
           <a:prstGeom prst="rect">
             <a:avLst/>
@@ -8256,7 +8314,7 @@
           <p:cNvPr id="4" name="Image 3">
             <a:extLst>
               <a:ext uri="{FF2B5EF4-FFF2-40B4-BE49-F238E27FC236}">
-                <a16:creationId xmlns:a16="http://schemas.microsoft.com/office/drawing/2014/main" id="{06A629EB-B976-1C2D-AE7A-1CF0ECC5B8ED}"/>
+                <a16:creationId xmlns:a16="http://schemas.microsoft.com/office/drawing/2014/main" id="{56A159CC-BC97-A655-0471-F51244BEABA8}"/>
               </a:ext>
             </a:extLst>
           </p:cNvPr>
@@ -8273,8 +8331,38 @@
         </p:blipFill>
         <p:spPr>
           <a:xfrm>
-            <a:off x="1291903" y="2058552"/>
-            <a:ext cx="9660850" cy="4644252"/>
+            <a:off x="771786" y="1766142"/>
+            <a:ext cx="10403625" cy="5012163"/>
+          </a:xfrm>
+          <a:prstGeom prst="rect">
+            <a:avLst/>
+          </a:prstGeom>
+        </p:spPr>
+      </p:pic>
+      <p:pic>
+        <p:nvPicPr>
+          <p:cNvPr id="5" name="Image 4">
+            <a:extLst>
+              <a:ext uri="{FF2B5EF4-FFF2-40B4-BE49-F238E27FC236}">
+                <a16:creationId xmlns:a16="http://schemas.microsoft.com/office/drawing/2014/main" id="{39B7404F-A5A6-6112-520D-8360C51766EF}"/>
+              </a:ext>
+            </a:extLst>
+          </p:cNvPr>
+          <p:cNvPicPr>
+            <a:picLocks noChangeAspect="1"/>
+          </p:cNvPicPr>
+          <p:nvPr/>
+        </p:nvPicPr>
+        <p:blipFill>
+          <a:blip r:embed="rId4"/>
+          <a:stretch>
+            <a:fillRect/>
+          </a:stretch>
+        </p:blipFill>
+        <p:spPr>
+          <a:xfrm>
+            <a:off x="2337153" y="3847894"/>
+            <a:ext cx="7668695" cy="1695687"/>
           </a:xfrm>
           <a:prstGeom prst="rect">
             <a:avLst/>
@@ -8284,7 +8372,7 @@
     </p:spTree>
     <p:extLst>
       <p:ext uri="{BB962C8B-B14F-4D97-AF65-F5344CB8AC3E}">
-        <p14:creationId xmlns:p14="http://schemas.microsoft.com/office/powerpoint/2010/main" val="3774767942"/>
+        <p14:creationId xmlns:p14="http://schemas.microsoft.com/office/powerpoint/2010/main" val="3510113114"/>
       </p:ext>
     </p:extLst>
   </p:cSld>
@@ -8316,7 +8404,7 @@
           <p:cNvPr id="2" name="Titre 1">
             <a:extLst>
               <a:ext uri="{FF2B5EF4-FFF2-40B4-BE49-F238E27FC236}">
-                <a16:creationId xmlns:a16="http://schemas.microsoft.com/office/drawing/2014/main" id="{9BF692DC-0B03-A67F-6C7C-D6643BC6A425}"/>
+                <a16:creationId xmlns:a16="http://schemas.microsoft.com/office/drawing/2014/main" id="{64CA944C-650E-872F-CDEB-F23DCF579310}"/>
               </a:ext>
             </a:extLst>
           </p:cNvPr>
@@ -8334,26 +8422,24 @@
           <a:p>
             <a:r>
               <a:rPr lang="fr-FR" dirty="0"/>
-              <a:t>Centre d’envoi</a:t>
+              <a:t>Désidératas Clubs</a:t>
             </a:r>
           </a:p>
         </p:txBody>
       </p:sp>
       <p:pic>
         <p:nvPicPr>
-          <p:cNvPr id="7170" name="Picture 2" descr="Centre d'envoi">
+          <p:cNvPr id="4098" name="Picture 2" descr="Import Rencontres">
             <a:extLst>
               <a:ext uri="{FF2B5EF4-FFF2-40B4-BE49-F238E27FC236}">
-                <a16:creationId xmlns:a16="http://schemas.microsoft.com/office/drawing/2014/main" id="{5C07D2D0-D00C-CB33-4908-1BA308069406}"/>
+                <a16:creationId xmlns:a16="http://schemas.microsoft.com/office/drawing/2014/main" id="{6684EB83-F2ED-DCD1-2718-087B4E0437E0}"/>
               </a:ext>
             </a:extLst>
           </p:cNvPr>
           <p:cNvPicPr>
-            <a:picLocks noGrp="1" noChangeAspect="1" noChangeArrowheads="1"/>
+            <a:picLocks noChangeAspect="1" noChangeArrowheads="1"/>
           </p:cNvPicPr>
-          <p:nvPr>
-            <p:ph idx="1"/>
-          </p:nvPr>
+          <p:nvPr/>
         </p:nvPicPr>
         <p:blipFill>
           <a:blip r:embed="rId2">
@@ -8370,8 +8456,8 @@
         </p:blipFill>
         <p:spPr bwMode="auto">
           <a:xfrm>
-            <a:off x="10620462" y="702388"/>
-            <a:ext cx="1470870" cy="1131778"/>
+            <a:off x="10780725" y="689644"/>
+            <a:ext cx="1287623" cy="1030098"/>
           </a:xfrm>
           <a:prstGeom prst="rect">
             <a:avLst/>
@@ -8393,7 +8479,7 @@
           <p:cNvPr id="5" name="Image 4">
             <a:extLst>
               <a:ext uri="{FF2B5EF4-FFF2-40B4-BE49-F238E27FC236}">
-                <a16:creationId xmlns:a16="http://schemas.microsoft.com/office/drawing/2014/main" id="{902C6DB1-9911-56DE-2049-CCE208CFD8E1}"/>
+                <a16:creationId xmlns:a16="http://schemas.microsoft.com/office/drawing/2014/main" id="{54F2B0D0-8A20-BBCD-DF0A-EE2EE0DE6BF5}"/>
               </a:ext>
             </a:extLst>
           </p:cNvPr>
@@ -8410,8 +8496,8 @@
         </p:blipFill>
         <p:spPr>
           <a:xfrm>
-            <a:off x="1501630" y="2132522"/>
-            <a:ext cx="9557618" cy="4587059"/>
+            <a:off x="1234911" y="2130631"/>
+            <a:ext cx="9545814" cy="4588951"/>
           </a:xfrm>
           <a:prstGeom prst="rect">
             <a:avLst/>
@@ -8421,7 +8507,7 @@
     </p:spTree>
     <p:extLst>
       <p:ext uri="{BB962C8B-B14F-4D97-AF65-F5344CB8AC3E}">
-        <p14:creationId xmlns:p14="http://schemas.microsoft.com/office/powerpoint/2010/main" val="3690824558"/>
+        <p14:creationId xmlns:p14="http://schemas.microsoft.com/office/powerpoint/2010/main" val="2279569518"/>
       </p:ext>
     </p:extLst>
   </p:cSld>
@@ -8453,7 +8539,7 @@
           <p:cNvPr id="2" name="Titre 1">
             <a:extLst>
               <a:ext uri="{FF2B5EF4-FFF2-40B4-BE49-F238E27FC236}">
-                <a16:creationId xmlns:a16="http://schemas.microsoft.com/office/drawing/2014/main" id="{002EF265-FED7-F930-DB1B-DFA67A7C9CFD}"/>
+                <a16:creationId xmlns:a16="http://schemas.microsoft.com/office/drawing/2014/main" id="{5468EA9C-CF84-3767-6023-E77D3947CC9C}"/>
               </a:ext>
             </a:extLst>
           </p:cNvPr>
@@ -8471,24 +8557,26 @@
           <a:p>
             <a:r>
               <a:rPr lang="fr-FR" dirty="0"/>
-              <a:t>Comptabilité</a:t>
+              <a:t>Nomination JA</a:t>
             </a:r>
           </a:p>
         </p:txBody>
       </p:sp>
       <p:pic>
         <p:nvPicPr>
-          <p:cNvPr id="8194" name="Picture 2" descr="Comptabilite">
+          <p:cNvPr id="5122" name="Picture 2" descr="Nomination JA">
             <a:extLst>
               <a:ext uri="{FF2B5EF4-FFF2-40B4-BE49-F238E27FC236}">
-                <a16:creationId xmlns:a16="http://schemas.microsoft.com/office/drawing/2014/main" id="{D24A8663-8036-9D28-A6A3-1D807EB96013}"/>
+                <a16:creationId xmlns:a16="http://schemas.microsoft.com/office/drawing/2014/main" id="{76066D18-0978-CA5D-7AD1-C2189B58B62B}"/>
               </a:ext>
             </a:extLst>
           </p:cNvPr>
           <p:cNvPicPr>
-            <a:picLocks noChangeAspect="1" noChangeArrowheads="1"/>
+            <a:picLocks noGrp="1" noChangeAspect="1" noChangeArrowheads="1"/>
           </p:cNvPicPr>
-          <p:nvPr/>
+          <p:nvPr>
+            <p:ph idx="1"/>
+          </p:nvPr>
         </p:nvPicPr>
         <p:blipFill>
           <a:blip r:embed="rId2">
@@ -8504,9 +8592,9 @@
           </a:stretch>
         </p:blipFill>
         <p:spPr bwMode="auto">
-          <a:xfrm>
-            <a:off x="10798770" y="753228"/>
-            <a:ext cx="1241180" cy="1055003"/>
+          <a:xfrm flipH="1">
+            <a:off x="10676289" y="860187"/>
+            <a:ext cx="1408444" cy="792443"/>
           </a:xfrm>
           <a:prstGeom prst="rect">
             <a:avLst/>
@@ -8528,7 +8616,7 @@
           <p:cNvPr id="5" name="Image 4">
             <a:extLst>
               <a:ext uri="{FF2B5EF4-FFF2-40B4-BE49-F238E27FC236}">
-                <a16:creationId xmlns:a16="http://schemas.microsoft.com/office/drawing/2014/main" id="{A7542A1A-5353-CFC0-F4C9-9BC24EF7389C}"/>
+                <a16:creationId xmlns:a16="http://schemas.microsoft.com/office/drawing/2014/main" id="{423F93F1-C8F4-9A60-2258-88061CCD6CA7}"/>
               </a:ext>
             </a:extLst>
           </p:cNvPr>
@@ -8545,8 +8633,8 @@
         </p:blipFill>
         <p:spPr>
           <a:xfrm>
-            <a:off x="1323554" y="2063859"/>
-            <a:ext cx="9754512" cy="4689279"/>
+            <a:off x="1427036" y="2067973"/>
+            <a:ext cx="9648250" cy="4643220"/>
           </a:xfrm>
           <a:prstGeom prst="rect">
             <a:avLst/>
@@ -8556,7 +8644,7 @@
     </p:spTree>
     <p:extLst>
       <p:ext uri="{BB962C8B-B14F-4D97-AF65-F5344CB8AC3E}">
-        <p14:creationId xmlns:p14="http://schemas.microsoft.com/office/powerpoint/2010/main" val="3993821954"/>
+        <p14:creationId xmlns:p14="http://schemas.microsoft.com/office/powerpoint/2010/main" val="3299174755"/>
       </p:ext>
     </p:extLst>
   </p:cSld>
@@ -8588,7 +8676,7 @@
           <p:cNvPr id="2" name="Titre 1">
             <a:extLst>
               <a:ext uri="{FF2B5EF4-FFF2-40B4-BE49-F238E27FC236}">
-                <a16:creationId xmlns:a16="http://schemas.microsoft.com/office/drawing/2014/main" id="{4AF09D7F-A1D7-A0A6-81DF-81B6D3AA7916}"/>
+                <a16:creationId xmlns:a16="http://schemas.microsoft.com/office/drawing/2014/main" id="{DFDBCE47-2A87-B2E4-868B-7C71124D4995}"/>
               </a:ext>
             </a:extLst>
           </p:cNvPr>
@@ -8606,17 +8694,17 @@
           <a:p>
             <a:r>
               <a:rPr lang="fr-FR" dirty="0"/>
-              <a:t>Statistique JA</a:t>
+              <a:t>Messagerie</a:t>
             </a:r>
           </a:p>
         </p:txBody>
       </p:sp>
       <p:pic>
         <p:nvPicPr>
-          <p:cNvPr id="9218" name="Picture 2" descr="Statistiques JA">
+          <p:cNvPr id="6146" name="Picture 2" descr="Messagerie">
             <a:extLst>
               <a:ext uri="{FF2B5EF4-FFF2-40B4-BE49-F238E27FC236}">
-                <a16:creationId xmlns:a16="http://schemas.microsoft.com/office/drawing/2014/main" id="{DF353A19-AF1F-936C-0446-18EE8D09154C}"/>
+                <a16:creationId xmlns:a16="http://schemas.microsoft.com/office/drawing/2014/main" id="{5D3D5C73-B4C3-CB83-BB3F-0641FD899940}"/>
               </a:ext>
             </a:extLst>
           </p:cNvPr>
@@ -8642,8 +8730,8 @@
         </p:blipFill>
         <p:spPr bwMode="auto">
           <a:xfrm>
-            <a:off x="10729519" y="920273"/>
-            <a:ext cx="1341931" cy="740746"/>
+            <a:off x="10912056" y="753228"/>
+            <a:ext cx="1080938" cy="1080938"/>
           </a:xfrm>
           <a:prstGeom prst="rect">
             <a:avLst/>
@@ -8662,10 +8750,10 @@
       </p:pic>
       <p:pic>
         <p:nvPicPr>
-          <p:cNvPr id="5" name="Image 4">
+          <p:cNvPr id="4" name="Image 3">
             <a:extLst>
               <a:ext uri="{FF2B5EF4-FFF2-40B4-BE49-F238E27FC236}">
-                <a16:creationId xmlns:a16="http://schemas.microsoft.com/office/drawing/2014/main" id="{6B07F5A8-61B5-608A-8857-1F909C5C8835}"/>
+                <a16:creationId xmlns:a16="http://schemas.microsoft.com/office/drawing/2014/main" id="{FEF57B06-3A85-379C-BBF1-FDE25E83CBDF}"/>
               </a:ext>
             </a:extLst>
           </p:cNvPr>
@@ -8682,8 +8770,8 @@
         </p:blipFill>
         <p:spPr>
           <a:xfrm>
-            <a:off x="1090569" y="2034015"/>
-            <a:ext cx="9840286" cy="4737915"/>
+            <a:off x="680320" y="1762466"/>
+            <a:ext cx="10289365" cy="4957116"/>
           </a:xfrm>
           <a:prstGeom prst="rect">
             <a:avLst/>
@@ -8693,7 +8781,7 @@
     </p:spTree>
     <p:extLst>
       <p:ext uri="{BB962C8B-B14F-4D97-AF65-F5344CB8AC3E}">
-        <p14:creationId xmlns:p14="http://schemas.microsoft.com/office/powerpoint/2010/main" val="3857667490"/>
+        <p14:creationId xmlns:p14="http://schemas.microsoft.com/office/powerpoint/2010/main" val="249029771"/>
       </p:ext>
     </p:extLst>
   </p:cSld>
@@ -8725,7 +8813,7 @@
           <p:cNvPr id="2" name="Titre 1">
             <a:extLst>
               <a:ext uri="{FF2B5EF4-FFF2-40B4-BE49-F238E27FC236}">
-                <a16:creationId xmlns:a16="http://schemas.microsoft.com/office/drawing/2014/main" id="{1A5D3C63-4AE0-2CC3-DFDC-87CB96EE72FA}"/>
+                <a16:creationId xmlns:a16="http://schemas.microsoft.com/office/drawing/2014/main" id="{DFDBCE47-2A87-B2E4-868B-7C71124D4995}"/>
               </a:ext>
             </a:extLst>
           </p:cNvPr>
@@ -8743,61 +8831,66 @@
           <a:p>
             <a:r>
               <a:rPr lang="fr-FR" dirty="0"/>
-              <a:t>Se déconnecter</a:t>
-            </a:r>
-          </a:p>
-        </p:txBody>
-      </p:sp>
-      <p:sp>
-        <p:nvSpPr>
-          <p:cNvPr id="3" name="Espace réservé du contenu 2">
+              <a:t>Messagerie</a:t>
+            </a:r>
+          </a:p>
+        </p:txBody>
+      </p:sp>
+      <p:pic>
+        <p:nvPicPr>
+          <p:cNvPr id="6146" name="Picture 2" descr="Messagerie">
             <a:extLst>
               <a:ext uri="{FF2B5EF4-FFF2-40B4-BE49-F238E27FC236}">
-                <a16:creationId xmlns:a16="http://schemas.microsoft.com/office/drawing/2014/main" id="{5FF77055-FDEE-34FA-D127-65B3F1351B7E}"/>
+                <a16:creationId xmlns:a16="http://schemas.microsoft.com/office/drawing/2014/main" id="{5D3D5C73-B4C3-CB83-BB3F-0641FD899940}"/>
               </a:ext>
             </a:extLst>
           </p:cNvPr>
-          <p:cNvSpPr>
-            <a:spLocks noGrp="1"/>
-          </p:cNvSpPr>
+          <p:cNvPicPr>
+            <a:picLocks noGrp="1" noChangeAspect="1" noChangeArrowheads="1"/>
+          </p:cNvPicPr>
           <p:nvPr>
             <p:ph idx="1"/>
           </p:nvPr>
-        </p:nvSpPr>
-        <p:spPr>
-          <a:xfrm>
-            <a:off x="680321" y="2336873"/>
-            <a:ext cx="9613861" cy="2033791"/>
-          </a:xfrm>
-        </p:spPr>
-        <p:txBody>
-          <a:bodyPr>
-            <a:normAutofit/>
-          </a:bodyPr>
-          <a:lstStyle/>
-          <a:p>
-            <a:r>
-              <a:rPr lang="fr-FR" sz="3600" dirty="0"/>
-              <a:t>C’est la fin de cette présentation.</a:t>
-            </a:r>
-          </a:p>
-          <a:p>
-            <a:endParaRPr lang="fr-FR" sz="3600" dirty="0"/>
-          </a:p>
-          <a:p>
-            <a:r>
-              <a:rPr lang="fr-FR" sz="3600" dirty="0"/>
-              <a:t>J’attend vos questions ?</a:t>
-            </a:r>
-          </a:p>
-        </p:txBody>
-      </p:sp>
+        </p:nvPicPr>
+        <p:blipFill>
+          <a:blip r:embed="rId2">
+            <a:extLst>
+              <a:ext uri="{28A0092B-C50C-407E-A947-70E740481C1C}">
+                <a14:useLocalDpi xmlns:a14="http://schemas.microsoft.com/office/drawing/2010/main" val="0"/>
+              </a:ext>
+            </a:extLst>
+          </a:blip>
+          <a:srcRect/>
+          <a:stretch>
+            <a:fillRect/>
+          </a:stretch>
+        </p:blipFill>
+        <p:spPr bwMode="auto">
+          <a:xfrm>
+            <a:off x="10912056" y="753228"/>
+            <a:ext cx="1080938" cy="1080938"/>
+          </a:xfrm>
+          <a:prstGeom prst="rect">
+            <a:avLst/>
+          </a:prstGeom>
+          <a:noFill/>
+          <a:extLst>
+            <a:ext uri="{909E8E84-426E-40DD-AFC4-6F175D3DCCD1}">
+              <a14:hiddenFill xmlns:a14="http://schemas.microsoft.com/office/drawing/2010/main">
+                <a:solidFill>
+                  <a:srgbClr val="FFFFFF"/>
+                </a:solidFill>
+              </a14:hiddenFill>
+            </a:ext>
+          </a:extLst>
+        </p:spPr>
+      </p:pic>
       <p:pic>
         <p:nvPicPr>
           <p:cNvPr id="5" name="Image 4">
             <a:extLst>
               <a:ext uri="{FF2B5EF4-FFF2-40B4-BE49-F238E27FC236}">
-                <a16:creationId xmlns:a16="http://schemas.microsoft.com/office/drawing/2014/main" id="{05C32665-54BA-FEB5-A57D-C0B75E92F851}"/>
+                <a16:creationId xmlns:a16="http://schemas.microsoft.com/office/drawing/2014/main" id="{89C4B344-9E06-3248-1146-9F2584261644}"/>
               </a:ext>
             </a:extLst>
           </p:cNvPr>
@@ -8807,15 +8900,45 @@
           <p:nvPr/>
         </p:nvPicPr>
         <p:blipFill>
-          <a:blip r:embed="rId2"/>
+          <a:blip r:embed="rId3"/>
           <a:stretch>
             <a:fillRect/>
           </a:stretch>
         </p:blipFill>
         <p:spPr>
           <a:xfrm>
-            <a:off x="10896787" y="769749"/>
-            <a:ext cx="1086002" cy="1047896"/>
+            <a:off x="259104" y="1834166"/>
+            <a:ext cx="8049748" cy="2943636"/>
+          </a:xfrm>
+          <a:prstGeom prst="rect">
+            <a:avLst/>
+          </a:prstGeom>
+        </p:spPr>
+      </p:pic>
+      <p:pic>
+        <p:nvPicPr>
+          <p:cNvPr id="7" name="Image 6">
+            <a:extLst>
+              <a:ext uri="{FF2B5EF4-FFF2-40B4-BE49-F238E27FC236}">
+                <a16:creationId xmlns:a16="http://schemas.microsoft.com/office/drawing/2014/main" id="{93E3E180-CB53-1B2B-B891-16F0CD5EFB27}"/>
+              </a:ext>
+            </a:extLst>
+          </p:cNvPr>
+          <p:cNvPicPr>
+            <a:picLocks noChangeAspect="1"/>
+          </p:cNvPicPr>
+          <p:nvPr/>
+        </p:nvPicPr>
+        <p:blipFill>
+          <a:blip r:embed="rId4"/>
+          <a:stretch>
+            <a:fillRect/>
+          </a:stretch>
+        </p:blipFill>
+        <p:spPr>
+          <a:xfrm>
+            <a:off x="1843571" y="4561318"/>
+            <a:ext cx="9964541" cy="2181529"/>
           </a:xfrm>
           <a:prstGeom prst="rect">
             <a:avLst/>
@@ -8825,7 +8948,279 @@
     </p:spTree>
     <p:extLst>
       <p:ext uri="{BB962C8B-B14F-4D97-AF65-F5344CB8AC3E}">
-        <p14:creationId xmlns:p14="http://schemas.microsoft.com/office/powerpoint/2010/main" val="3163169573"/>
+        <p14:creationId xmlns:p14="http://schemas.microsoft.com/office/powerpoint/2010/main" val="3774767942"/>
+      </p:ext>
+    </p:extLst>
+  </p:cSld>
+  <p:clrMapOvr>
+    <a:masterClrMapping/>
+  </p:clrMapOvr>
+</p:sld>
+</file>
+
+<file path=ppt/slides/slide18.xml><?xml version="1.0" encoding="utf-8"?>
+<p:sld xmlns:a="http://schemas.openxmlformats.org/drawingml/2006/main" xmlns:r="http://schemas.openxmlformats.org/officeDocument/2006/relationships" xmlns:p="http://schemas.openxmlformats.org/presentationml/2006/main">
+  <p:cSld>
+    <p:spTree>
+      <p:nvGrpSpPr>
+        <p:cNvPr id="1" name=""/>
+        <p:cNvGrpSpPr/>
+        <p:nvPr/>
+      </p:nvGrpSpPr>
+      <p:grpSpPr>
+        <a:xfrm>
+          <a:off x="0" y="0"/>
+          <a:ext cx="0" cy="0"/>
+          <a:chOff x="0" y="0"/>
+          <a:chExt cx="0" cy="0"/>
+        </a:xfrm>
+      </p:grpSpPr>
+      <p:sp>
+        <p:nvSpPr>
+          <p:cNvPr id="2" name="Titre 1">
+            <a:extLst>
+              <a:ext uri="{FF2B5EF4-FFF2-40B4-BE49-F238E27FC236}">
+                <a16:creationId xmlns:a16="http://schemas.microsoft.com/office/drawing/2014/main" id="{9BF692DC-0B03-A67F-6C7C-D6643BC6A425}"/>
+              </a:ext>
+            </a:extLst>
+          </p:cNvPr>
+          <p:cNvSpPr>
+            <a:spLocks noGrp="1"/>
+          </p:cNvSpPr>
+          <p:nvPr>
+            <p:ph type="title"/>
+          </p:nvPr>
+        </p:nvSpPr>
+        <p:spPr/>
+        <p:txBody>
+          <a:bodyPr/>
+          <a:lstStyle/>
+          <a:p>
+            <a:r>
+              <a:rPr lang="fr-FR" dirty="0"/>
+              <a:t>Centre d’envoi</a:t>
+            </a:r>
+          </a:p>
+        </p:txBody>
+      </p:sp>
+      <p:pic>
+        <p:nvPicPr>
+          <p:cNvPr id="7170" name="Picture 2" descr="Centre d'envoi">
+            <a:extLst>
+              <a:ext uri="{FF2B5EF4-FFF2-40B4-BE49-F238E27FC236}">
+                <a16:creationId xmlns:a16="http://schemas.microsoft.com/office/drawing/2014/main" id="{5C07D2D0-D00C-CB33-4908-1BA308069406}"/>
+              </a:ext>
+            </a:extLst>
+          </p:cNvPr>
+          <p:cNvPicPr>
+            <a:picLocks noGrp="1" noChangeAspect="1" noChangeArrowheads="1"/>
+          </p:cNvPicPr>
+          <p:nvPr>
+            <p:ph idx="1"/>
+          </p:nvPr>
+        </p:nvPicPr>
+        <p:blipFill>
+          <a:blip r:embed="rId2">
+            <a:extLst>
+              <a:ext uri="{28A0092B-C50C-407E-A947-70E740481C1C}">
+                <a14:useLocalDpi xmlns:a14="http://schemas.microsoft.com/office/drawing/2010/main" val="0"/>
+              </a:ext>
+            </a:extLst>
+          </a:blip>
+          <a:srcRect/>
+          <a:stretch>
+            <a:fillRect/>
+          </a:stretch>
+        </p:blipFill>
+        <p:spPr bwMode="auto">
+          <a:xfrm>
+            <a:off x="10620462" y="702388"/>
+            <a:ext cx="1470870" cy="1131778"/>
+          </a:xfrm>
+          <a:prstGeom prst="rect">
+            <a:avLst/>
+          </a:prstGeom>
+          <a:noFill/>
+          <a:extLst>
+            <a:ext uri="{909E8E84-426E-40DD-AFC4-6F175D3DCCD1}">
+              <a14:hiddenFill xmlns:a14="http://schemas.microsoft.com/office/drawing/2010/main">
+                <a:solidFill>
+                  <a:srgbClr val="FFFFFF"/>
+                </a:solidFill>
+              </a14:hiddenFill>
+            </a:ext>
+          </a:extLst>
+        </p:spPr>
+      </p:pic>
+      <p:pic>
+        <p:nvPicPr>
+          <p:cNvPr id="4" name="Image 3">
+            <a:extLst>
+              <a:ext uri="{FF2B5EF4-FFF2-40B4-BE49-F238E27FC236}">
+                <a16:creationId xmlns:a16="http://schemas.microsoft.com/office/drawing/2014/main" id="{87A9B126-1D38-F885-4854-45496FE4B684}"/>
+              </a:ext>
+            </a:extLst>
+          </p:cNvPr>
+          <p:cNvPicPr>
+            <a:picLocks noChangeAspect="1"/>
+          </p:cNvPicPr>
+          <p:nvPr/>
+        </p:nvPicPr>
+        <p:blipFill>
+          <a:blip r:embed="rId3"/>
+          <a:stretch>
+            <a:fillRect/>
+          </a:stretch>
+        </p:blipFill>
+        <p:spPr>
+          <a:xfrm>
+            <a:off x="589947" y="1700732"/>
+            <a:ext cx="10030515" cy="4999585"/>
+          </a:xfrm>
+          <a:prstGeom prst="rect">
+            <a:avLst/>
+          </a:prstGeom>
+        </p:spPr>
+      </p:pic>
+    </p:spTree>
+    <p:extLst>
+      <p:ext uri="{BB962C8B-B14F-4D97-AF65-F5344CB8AC3E}">
+        <p14:creationId xmlns:p14="http://schemas.microsoft.com/office/powerpoint/2010/main" val="3690824558"/>
+      </p:ext>
+    </p:extLst>
+  </p:cSld>
+  <p:clrMapOvr>
+    <a:masterClrMapping/>
+  </p:clrMapOvr>
+</p:sld>
+</file>
+
+<file path=ppt/slides/slide19.xml><?xml version="1.0" encoding="utf-8"?>
+<p:sld xmlns:a="http://schemas.openxmlformats.org/drawingml/2006/main" xmlns:r="http://schemas.openxmlformats.org/officeDocument/2006/relationships" xmlns:p="http://schemas.openxmlformats.org/presentationml/2006/main">
+  <p:cSld>
+    <p:spTree>
+      <p:nvGrpSpPr>
+        <p:cNvPr id="1" name=""/>
+        <p:cNvGrpSpPr/>
+        <p:nvPr/>
+      </p:nvGrpSpPr>
+      <p:grpSpPr>
+        <a:xfrm>
+          <a:off x="0" y="0"/>
+          <a:ext cx="0" cy="0"/>
+          <a:chOff x="0" y="0"/>
+          <a:chExt cx="0" cy="0"/>
+        </a:xfrm>
+      </p:grpSpPr>
+      <p:sp>
+        <p:nvSpPr>
+          <p:cNvPr id="2" name="Titre 1">
+            <a:extLst>
+              <a:ext uri="{FF2B5EF4-FFF2-40B4-BE49-F238E27FC236}">
+                <a16:creationId xmlns:a16="http://schemas.microsoft.com/office/drawing/2014/main" id="{002EF265-FED7-F930-DB1B-DFA67A7C9CFD}"/>
+              </a:ext>
+            </a:extLst>
+          </p:cNvPr>
+          <p:cNvSpPr>
+            <a:spLocks noGrp="1"/>
+          </p:cNvSpPr>
+          <p:nvPr>
+            <p:ph type="title"/>
+          </p:nvPr>
+        </p:nvSpPr>
+        <p:spPr/>
+        <p:txBody>
+          <a:bodyPr/>
+          <a:lstStyle/>
+          <a:p>
+            <a:r>
+              <a:rPr lang="fr-FR" dirty="0"/>
+              <a:t>Comptabilité</a:t>
+            </a:r>
+          </a:p>
+        </p:txBody>
+      </p:sp>
+      <p:pic>
+        <p:nvPicPr>
+          <p:cNvPr id="8194" name="Picture 2" descr="Comptabilite">
+            <a:extLst>
+              <a:ext uri="{FF2B5EF4-FFF2-40B4-BE49-F238E27FC236}">
+                <a16:creationId xmlns:a16="http://schemas.microsoft.com/office/drawing/2014/main" id="{D24A8663-8036-9D28-A6A3-1D807EB96013}"/>
+              </a:ext>
+            </a:extLst>
+          </p:cNvPr>
+          <p:cNvPicPr>
+            <a:picLocks noChangeAspect="1" noChangeArrowheads="1"/>
+          </p:cNvPicPr>
+          <p:nvPr/>
+        </p:nvPicPr>
+        <p:blipFill>
+          <a:blip r:embed="rId2">
+            <a:extLst>
+              <a:ext uri="{28A0092B-C50C-407E-A947-70E740481C1C}">
+                <a14:useLocalDpi xmlns:a14="http://schemas.microsoft.com/office/drawing/2010/main" val="0"/>
+              </a:ext>
+            </a:extLst>
+          </a:blip>
+          <a:srcRect/>
+          <a:stretch>
+            <a:fillRect/>
+          </a:stretch>
+        </p:blipFill>
+        <p:spPr bwMode="auto">
+          <a:xfrm>
+            <a:off x="10798770" y="753228"/>
+            <a:ext cx="1241180" cy="1055003"/>
+          </a:xfrm>
+          <a:prstGeom prst="rect">
+            <a:avLst/>
+          </a:prstGeom>
+          <a:noFill/>
+          <a:extLst>
+            <a:ext uri="{909E8E84-426E-40DD-AFC4-6F175D3DCCD1}">
+              <a14:hiddenFill xmlns:a14="http://schemas.microsoft.com/office/drawing/2010/main">
+                <a:solidFill>
+                  <a:srgbClr val="FFFFFF"/>
+                </a:solidFill>
+              </a14:hiddenFill>
+            </a:ext>
+          </a:extLst>
+        </p:spPr>
+      </p:pic>
+      <p:pic>
+        <p:nvPicPr>
+          <p:cNvPr id="5" name="Image 4">
+            <a:extLst>
+              <a:ext uri="{FF2B5EF4-FFF2-40B4-BE49-F238E27FC236}">
+                <a16:creationId xmlns:a16="http://schemas.microsoft.com/office/drawing/2014/main" id="{A7542A1A-5353-CFC0-F4C9-9BC24EF7389C}"/>
+              </a:ext>
+            </a:extLst>
+          </p:cNvPr>
+          <p:cNvPicPr>
+            <a:picLocks noChangeAspect="1"/>
+          </p:cNvPicPr>
+          <p:nvPr/>
+        </p:nvPicPr>
+        <p:blipFill>
+          <a:blip r:embed="rId3"/>
+          <a:stretch>
+            <a:fillRect/>
+          </a:stretch>
+        </p:blipFill>
+        <p:spPr>
+          <a:xfrm>
+            <a:off x="1323554" y="2063859"/>
+            <a:ext cx="9754512" cy="4689279"/>
+          </a:xfrm>
+          <a:prstGeom prst="rect">
+            <a:avLst/>
+          </a:prstGeom>
+        </p:spPr>
+      </p:pic>
+    </p:spTree>
+    <p:extLst>
+      <p:ext uri="{BB962C8B-B14F-4D97-AF65-F5344CB8AC3E}">
+        <p14:creationId xmlns:p14="http://schemas.microsoft.com/office/powerpoint/2010/main" val="3993821954"/>
       </p:ext>
     </p:extLst>
   </p:cSld>
@@ -8912,10 +9307,10 @@
       </p:pic>
       <p:pic>
         <p:nvPicPr>
-          <p:cNvPr id="11" name="Image 10">
+          <p:cNvPr id="4" name="Image 3">
             <a:extLst>
               <a:ext uri="{FF2B5EF4-FFF2-40B4-BE49-F238E27FC236}">
-                <a16:creationId xmlns:a16="http://schemas.microsoft.com/office/drawing/2014/main" id="{14EAEC1C-1EA4-7DF2-85AB-059C33EAECBF}"/>
+                <a16:creationId xmlns:a16="http://schemas.microsoft.com/office/drawing/2014/main" id="{DFEA72CE-2FE9-C373-603D-2B07C67CCAC9}"/>
               </a:ext>
             </a:extLst>
           </p:cNvPr>
@@ -8932,8 +9327,8 @@
         </p:blipFill>
         <p:spPr>
           <a:xfrm>
-            <a:off x="3645018" y="2336873"/>
-            <a:ext cx="5334000" cy="3457575"/>
+            <a:off x="3451734" y="2473355"/>
+            <a:ext cx="5439534" cy="3620005"/>
           </a:xfrm>
           <a:prstGeom prst="rect">
             <a:avLst/>
@@ -8944,6 +9339,275 @@
     <p:extLst>
       <p:ext uri="{BB962C8B-B14F-4D97-AF65-F5344CB8AC3E}">
         <p14:creationId xmlns:p14="http://schemas.microsoft.com/office/powerpoint/2010/main" val="1688564247"/>
+      </p:ext>
+    </p:extLst>
+  </p:cSld>
+  <p:clrMapOvr>
+    <a:masterClrMapping/>
+  </p:clrMapOvr>
+</p:sld>
+</file>
+
+<file path=ppt/slides/slide20.xml><?xml version="1.0" encoding="utf-8"?>
+<p:sld xmlns:a="http://schemas.openxmlformats.org/drawingml/2006/main" xmlns:r="http://schemas.openxmlformats.org/officeDocument/2006/relationships" xmlns:p="http://schemas.openxmlformats.org/presentationml/2006/main">
+  <p:cSld>
+    <p:spTree>
+      <p:nvGrpSpPr>
+        <p:cNvPr id="1" name=""/>
+        <p:cNvGrpSpPr/>
+        <p:nvPr/>
+      </p:nvGrpSpPr>
+      <p:grpSpPr>
+        <a:xfrm>
+          <a:off x="0" y="0"/>
+          <a:ext cx="0" cy="0"/>
+          <a:chOff x="0" y="0"/>
+          <a:chExt cx="0" cy="0"/>
+        </a:xfrm>
+      </p:grpSpPr>
+      <p:sp>
+        <p:nvSpPr>
+          <p:cNvPr id="2" name="Titre 1">
+            <a:extLst>
+              <a:ext uri="{FF2B5EF4-FFF2-40B4-BE49-F238E27FC236}">
+                <a16:creationId xmlns:a16="http://schemas.microsoft.com/office/drawing/2014/main" id="{4AF09D7F-A1D7-A0A6-81DF-81B6D3AA7916}"/>
+              </a:ext>
+            </a:extLst>
+          </p:cNvPr>
+          <p:cNvSpPr>
+            <a:spLocks noGrp="1"/>
+          </p:cNvSpPr>
+          <p:nvPr>
+            <p:ph type="title"/>
+          </p:nvPr>
+        </p:nvSpPr>
+        <p:spPr/>
+        <p:txBody>
+          <a:bodyPr/>
+          <a:lstStyle/>
+          <a:p>
+            <a:r>
+              <a:rPr lang="fr-FR" dirty="0"/>
+              <a:t>Statistique JA</a:t>
+            </a:r>
+          </a:p>
+        </p:txBody>
+      </p:sp>
+      <p:pic>
+        <p:nvPicPr>
+          <p:cNvPr id="9218" name="Picture 2" descr="Statistiques JA">
+            <a:extLst>
+              <a:ext uri="{FF2B5EF4-FFF2-40B4-BE49-F238E27FC236}">
+                <a16:creationId xmlns:a16="http://schemas.microsoft.com/office/drawing/2014/main" id="{DF353A19-AF1F-936C-0446-18EE8D09154C}"/>
+              </a:ext>
+            </a:extLst>
+          </p:cNvPr>
+          <p:cNvPicPr>
+            <a:picLocks noGrp="1" noChangeAspect="1" noChangeArrowheads="1"/>
+          </p:cNvPicPr>
+          <p:nvPr>
+            <p:ph idx="1"/>
+          </p:nvPr>
+        </p:nvPicPr>
+        <p:blipFill>
+          <a:blip r:embed="rId2">
+            <a:extLst>
+              <a:ext uri="{28A0092B-C50C-407E-A947-70E740481C1C}">
+                <a14:useLocalDpi xmlns:a14="http://schemas.microsoft.com/office/drawing/2010/main" val="0"/>
+              </a:ext>
+            </a:extLst>
+          </a:blip>
+          <a:srcRect/>
+          <a:stretch>
+            <a:fillRect/>
+          </a:stretch>
+        </p:blipFill>
+        <p:spPr bwMode="auto">
+          <a:xfrm>
+            <a:off x="10729519" y="920273"/>
+            <a:ext cx="1341931" cy="740746"/>
+          </a:xfrm>
+          <a:prstGeom prst="rect">
+            <a:avLst/>
+          </a:prstGeom>
+          <a:noFill/>
+          <a:extLst>
+            <a:ext uri="{909E8E84-426E-40DD-AFC4-6F175D3DCCD1}">
+              <a14:hiddenFill xmlns:a14="http://schemas.microsoft.com/office/drawing/2010/main">
+                <a:solidFill>
+                  <a:srgbClr val="FFFFFF"/>
+                </a:solidFill>
+              </a14:hiddenFill>
+            </a:ext>
+          </a:extLst>
+        </p:spPr>
+      </p:pic>
+      <p:pic>
+        <p:nvPicPr>
+          <p:cNvPr id="5" name="Image 4">
+            <a:extLst>
+              <a:ext uri="{FF2B5EF4-FFF2-40B4-BE49-F238E27FC236}">
+                <a16:creationId xmlns:a16="http://schemas.microsoft.com/office/drawing/2014/main" id="{6B07F5A8-61B5-608A-8857-1F909C5C8835}"/>
+              </a:ext>
+            </a:extLst>
+          </p:cNvPr>
+          <p:cNvPicPr>
+            <a:picLocks noChangeAspect="1"/>
+          </p:cNvPicPr>
+          <p:nvPr/>
+        </p:nvPicPr>
+        <p:blipFill>
+          <a:blip r:embed="rId3"/>
+          <a:stretch>
+            <a:fillRect/>
+          </a:stretch>
+        </p:blipFill>
+        <p:spPr>
+          <a:xfrm>
+            <a:off x="1090569" y="2034015"/>
+            <a:ext cx="9840286" cy="4737915"/>
+          </a:xfrm>
+          <a:prstGeom prst="rect">
+            <a:avLst/>
+          </a:prstGeom>
+        </p:spPr>
+      </p:pic>
+    </p:spTree>
+    <p:extLst>
+      <p:ext uri="{BB962C8B-B14F-4D97-AF65-F5344CB8AC3E}">
+        <p14:creationId xmlns:p14="http://schemas.microsoft.com/office/powerpoint/2010/main" val="3857667490"/>
+      </p:ext>
+    </p:extLst>
+  </p:cSld>
+  <p:clrMapOvr>
+    <a:masterClrMapping/>
+  </p:clrMapOvr>
+</p:sld>
+</file>
+
+<file path=ppt/slides/slide21.xml><?xml version="1.0" encoding="utf-8"?>
+<p:sld xmlns:a="http://schemas.openxmlformats.org/drawingml/2006/main" xmlns:r="http://schemas.openxmlformats.org/officeDocument/2006/relationships" xmlns:p="http://schemas.openxmlformats.org/presentationml/2006/main">
+  <p:cSld>
+    <p:spTree>
+      <p:nvGrpSpPr>
+        <p:cNvPr id="1" name=""/>
+        <p:cNvGrpSpPr/>
+        <p:nvPr/>
+      </p:nvGrpSpPr>
+      <p:grpSpPr>
+        <a:xfrm>
+          <a:off x="0" y="0"/>
+          <a:ext cx="0" cy="0"/>
+          <a:chOff x="0" y="0"/>
+          <a:chExt cx="0" cy="0"/>
+        </a:xfrm>
+      </p:grpSpPr>
+      <p:sp>
+        <p:nvSpPr>
+          <p:cNvPr id="2" name="Titre 1">
+            <a:extLst>
+              <a:ext uri="{FF2B5EF4-FFF2-40B4-BE49-F238E27FC236}">
+                <a16:creationId xmlns:a16="http://schemas.microsoft.com/office/drawing/2014/main" id="{1A5D3C63-4AE0-2CC3-DFDC-87CB96EE72FA}"/>
+              </a:ext>
+            </a:extLst>
+          </p:cNvPr>
+          <p:cNvSpPr>
+            <a:spLocks noGrp="1"/>
+          </p:cNvSpPr>
+          <p:nvPr>
+            <p:ph type="title"/>
+          </p:nvPr>
+        </p:nvSpPr>
+        <p:spPr/>
+        <p:txBody>
+          <a:bodyPr/>
+          <a:lstStyle/>
+          <a:p>
+            <a:r>
+              <a:rPr lang="fr-FR" dirty="0"/>
+              <a:t>Se déconnecter</a:t>
+            </a:r>
+          </a:p>
+        </p:txBody>
+      </p:sp>
+      <p:sp>
+        <p:nvSpPr>
+          <p:cNvPr id="3" name="Espace réservé du contenu 2">
+            <a:extLst>
+              <a:ext uri="{FF2B5EF4-FFF2-40B4-BE49-F238E27FC236}">
+                <a16:creationId xmlns:a16="http://schemas.microsoft.com/office/drawing/2014/main" id="{5FF77055-FDEE-34FA-D127-65B3F1351B7E}"/>
+              </a:ext>
+            </a:extLst>
+          </p:cNvPr>
+          <p:cNvSpPr>
+            <a:spLocks noGrp="1"/>
+          </p:cNvSpPr>
+          <p:nvPr>
+            <p:ph idx="1"/>
+          </p:nvPr>
+        </p:nvSpPr>
+        <p:spPr>
+          <a:xfrm>
+            <a:off x="1061415" y="2990044"/>
+            <a:ext cx="9613861" cy="2033791"/>
+          </a:xfrm>
+        </p:spPr>
+        <p:txBody>
+          <a:bodyPr>
+            <a:normAutofit/>
+          </a:bodyPr>
+          <a:lstStyle/>
+          <a:p>
+            <a:r>
+              <a:rPr lang="fr-FR" sz="3600" dirty="0"/>
+              <a:t>C’est la fin de cette présentation.</a:t>
+            </a:r>
+          </a:p>
+          <a:p>
+            <a:endParaRPr lang="fr-FR" sz="3600" dirty="0"/>
+          </a:p>
+          <a:p>
+            <a:r>
+              <a:rPr lang="fr-FR" sz="3600" dirty="0"/>
+              <a:t>J’attend vos questions ?</a:t>
+            </a:r>
+          </a:p>
+        </p:txBody>
+      </p:sp>
+      <p:pic>
+        <p:nvPicPr>
+          <p:cNvPr id="6" name="Image 5">
+            <a:extLst>
+              <a:ext uri="{FF2B5EF4-FFF2-40B4-BE49-F238E27FC236}">
+                <a16:creationId xmlns:a16="http://schemas.microsoft.com/office/drawing/2014/main" id="{C97D8B7C-C470-8536-74AA-7171DADA3F1B}"/>
+              </a:ext>
+            </a:extLst>
+          </p:cNvPr>
+          <p:cNvPicPr>
+            <a:picLocks noChangeAspect="1"/>
+          </p:cNvPicPr>
+          <p:nvPr/>
+        </p:nvPicPr>
+        <p:blipFill>
+          <a:blip r:embed="rId2"/>
+          <a:stretch>
+            <a:fillRect/>
+          </a:stretch>
+        </p:blipFill>
+        <p:spPr>
+          <a:xfrm>
+            <a:off x="10675276" y="753227"/>
+            <a:ext cx="1438592" cy="983293"/>
+          </a:xfrm>
+          <a:prstGeom prst="rect">
+            <a:avLst/>
+          </a:prstGeom>
+        </p:spPr>
+      </p:pic>
+    </p:spTree>
+    <p:extLst>
+      <p:ext uri="{BB962C8B-B14F-4D97-AF65-F5344CB8AC3E}">
+        <p14:creationId xmlns:p14="http://schemas.microsoft.com/office/powerpoint/2010/main" val="3163169573"/>
       </p:ext>
     </p:extLst>
   </p:cSld>
@@ -9000,36 +9664,6 @@
       </p:sp>
       <p:pic>
         <p:nvPicPr>
-          <p:cNvPr id="13" name="Image 12">
-            <a:extLst>
-              <a:ext uri="{FF2B5EF4-FFF2-40B4-BE49-F238E27FC236}">
-                <a16:creationId xmlns:a16="http://schemas.microsoft.com/office/drawing/2014/main" id="{F8430F63-C89C-E22E-45C4-7EF9DA109C9A}"/>
-              </a:ext>
-            </a:extLst>
-          </p:cNvPr>
-          <p:cNvPicPr>
-            <a:picLocks noChangeAspect="1"/>
-          </p:cNvPicPr>
-          <p:nvPr/>
-        </p:nvPicPr>
-        <p:blipFill>
-          <a:blip r:embed="rId2"/>
-          <a:stretch>
-            <a:fillRect/>
-          </a:stretch>
-        </p:blipFill>
-        <p:spPr>
-          <a:xfrm>
-            <a:off x="1577131" y="2153535"/>
-            <a:ext cx="9376014" cy="4507324"/>
-          </a:xfrm>
-          <a:prstGeom prst="rect">
-            <a:avLst/>
-          </a:prstGeom>
-        </p:spPr>
-      </p:pic>
-      <p:pic>
-        <p:nvPicPr>
           <p:cNvPr id="1026" name="Picture 2" descr="Arbitre">
             <a:extLst>
               <a:ext uri="{FF2B5EF4-FFF2-40B4-BE49-F238E27FC236}">
@@ -9043,7 +9677,7 @@
           <p:nvPr/>
         </p:nvPicPr>
         <p:blipFill>
-          <a:blip r:embed="rId3">
+          <a:blip r:embed="rId2">
             <a:extLst>
               <a:ext uri="{28A0092B-C50C-407E-A947-70E740481C1C}">
                 <a14:useLocalDpi xmlns:a14="http://schemas.microsoft.com/office/drawing/2010/main" val="0"/>
@@ -9073,6 +9707,36 @@
               </a14:hiddenFill>
             </a:ext>
           </a:extLst>
+        </p:spPr>
+      </p:pic>
+      <p:pic>
+        <p:nvPicPr>
+          <p:cNvPr id="4" name="Image 3">
+            <a:extLst>
+              <a:ext uri="{FF2B5EF4-FFF2-40B4-BE49-F238E27FC236}">
+                <a16:creationId xmlns:a16="http://schemas.microsoft.com/office/drawing/2014/main" id="{CA1CA9A5-89E7-4365-AF94-B9A6B1CBD408}"/>
+              </a:ext>
+            </a:extLst>
+          </p:cNvPr>
+          <p:cNvPicPr>
+            <a:picLocks noChangeAspect="1"/>
+          </p:cNvPicPr>
+          <p:nvPr/>
+        </p:nvPicPr>
+        <p:blipFill>
+          <a:blip r:embed="rId3"/>
+          <a:stretch>
+            <a:fillRect/>
+          </a:stretch>
+        </p:blipFill>
+        <p:spPr>
+          <a:xfrm>
+            <a:off x="1579119" y="2191554"/>
+            <a:ext cx="9374026" cy="4511250"/>
+          </a:xfrm>
+          <a:prstGeom prst="rect">
+            <a:avLst/>
+          </a:prstGeom>
         </p:spPr>
       </p:pic>
     </p:spTree>
@@ -9110,7 +9774,7 @@
           <p:cNvPr id="2" name="Titre 1">
             <a:extLst>
               <a:ext uri="{FF2B5EF4-FFF2-40B4-BE49-F238E27FC236}">
-                <a16:creationId xmlns:a16="http://schemas.microsoft.com/office/drawing/2014/main" id="{88173AE3-B121-232C-D4D9-F6BE4A2CCA13}"/>
+                <a16:creationId xmlns:a16="http://schemas.microsoft.com/office/drawing/2014/main" id="{95C6ECDA-40C3-3289-8330-1CE9546108FE}"/>
               </a:ext>
             </a:extLst>
           </p:cNvPr>
@@ -9128,17 +9792,17 @@
           <a:p>
             <a:r>
               <a:rPr lang="fr-FR" dirty="0"/>
-              <a:t>Juge Arbitre</a:t>
+              <a:t>Le menu principal</a:t>
             </a:r>
           </a:p>
         </p:txBody>
       </p:sp>
       <p:pic>
         <p:nvPicPr>
-          <p:cNvPr id="2050" name="Picture 2" descr="Arbitre">
+          <p:cNvPr id="1026" name="Picture 2" descr="Arbitre">
             <a:extLst>
               <a:ext uri="{FF2B5EF4-FFF2-40B4-BE49-F238E27FC236}">
-                <a16:creationId xmlns:a16="http://schemas.microsoft.com/office/drawing/2014/main" id="{B491C557-E6A7-804D-9274-518259E2CDCF}"/>
+                <a16:creationId xmlns:a16="http://schemas.microsoft.com/office/drawing/2014/main" id="{B52DDEEE-A2C6-6603-3B64-0F11D4E4A936}"/>
               </a:ext>
             </a:extLst>
           </p:cNvPr>
@@ -9162,8 +9826,8 @@
         </p:blipFill>
         <p:spPr bwMode="auto">
           <a:xfrm>
-            <a:off x="10842030" y="673147"/>
-            <a:ext cx="1171006" cy="1161019"/>
+            <a:off x="10953145" y="789591"/>
+            <a:ext cx="1053561" cy="1044575"/>
           </a:xfrm>
           <a:prstGeom prst="rect">
             <a:avLst/>
@@ -9182,10 +9846,10 @@
       </p:pic>
       <p:pic>
         <p:nvPicPr>
-          <p:cNvPr id="5" name="Image 4">
+          <p:cNvPr id="4" name="Image 3">
             <a:extLst>
               <a:ext uri="{FF2B5EF4-FFF2-40B4-BE49-F238E27FC236}">
-                <a16:creationId xmlns:a16="http://schemas.microsoft.com/office/drawing/2014/main" id="{5DFE1B73-FF33-25AA-7056-F5E7F3958015}"/>
+                <a16:creationId xmlns:a16="http://schemas.microsoft.com/office/drawing/2014/main" id="{CA1CA9A5-89E7-4365-AF94-B9A6B1CBD408}"/>
               </a:ext>
             </a:extLst>
           </p:cNvPr>
@@ -9202,8 +9866,38 @@
         </p:blipFill>
         <p:spPr>
           <a:xfrm>
-            <a:off x="1426127" y="2125699"/>
-            <a:ext cx="9613861" cy="4626671"/>
+            <a:off x="1579119" y="2191554"/>
+            <a:ext cx="9374026" cy="4511250"/>
+          </a:xfrm>
+          <a:prstGeom prst="rect">
+            <a:avLst/>
+          </a:prstGeom>
+        </p:spPr>
+      </p:pic>
+      <p:pic>
+        <p:nvPicPr>
+          <p:cNvPr id="5" name="Image 4">
+            <a:extLst>
+              <a:ext uri="{FF2B5EF4-FFF2-40B4-BE49-F238E27FC236}">
+                <a16:creationId xmlns:a16="http://schemas.microsoft.com/office/drawing/2014/main" id="{ACB2B2B8-DD58-A0F7-C540-C7F6D5779A08}"/>
+              </a:ext>
+            </a:extLst>
+          </p:cNvPr>
+          <p:cNvPicPr>
+            <a:picLocks noChangeAspect="1"/>
+          </p:cNvPicPr>
+          <p:nvPr/>
+        </p:nvPicPr>
+        <p:blipFill>
+          <a:blip r:embed="rId4"/>
+          <a:stretch>
+            <a:fillRect/>
+          </a:stretch>
+        </p:blipFill>
+        <p:spPr>
+          <a:xfrm>
+            <a:off x="2422258" y="3429000"/>
+            <a:ext cx="7687748" cy="1676634"/>
           </a:xfrm>
           <a:prstGeom prst="rect">
             <a:avLst/>
@@ -9213,7 +9907,7 @@
     </p:spTree>
     <p:extLst>
       <p:ext uri="{BB962C8B-B14F-4D97-AF65-F5344CB8AC3E}">
-        <p14:creationId xmlns:p14="http://schemas.microsoft.com/office/powerpoint/2010/main" val="1000226763"/>
+        <p14:creationId xmlns:p14="http://schemas.microsoft.com/office/powerpoint/2010/main" val="526960068"/>
       </p:ext>
     </p:extLst>
   </p:cSld>
@@ -9245,7 +9939,7 @@
           <p:cNvPr id="2" name="Titre 1">
             <a:extLst>
               <a:ext uri="{FF2B5EF4-FFF2-40B4-BE49-F238E27FC236}">
-                <a16:creationId xmlns:a16="http://schemas.microsoft.com/office/drawing/2014/main" id="{88173AE3-B121-232C-D4D9-F6BE4A2CCA13}"/>
+                <a16:creationId xmlns:a16="http://schemas.microsoft.com/office/drawing/2014/main" id="{95C6ECDA-40C3-3289-8330-1CE9546108FE}"/>
               </a:ext>
             </a:extLst>
           </p:cNvPr>
@@ -9263,17 +9957,17 @@
           <a:p>
             <a:r>
               <a:rPr lang="fr-FR" dirty="0"/>
-              <a:t>Juge Arbitre</a:t>
+              <a:t>Le menu principal</a:t>
             </a:r>
           </a:p>
         </p:txBody>
       </p:sp>
       <p:pic>
         <p:nvPicPr>
-          <p:cNvPr id="2050" name="Picture 2" descr="Arbitre">
+          <p:cNvPr id="1026" name="Picture 2" descr="Arbitre">
             <a:extLst>
               <a:ext uri="{FF2B5EF4-FFF2-40B4-BE49-F238E27FC236}">
-                <a16:creationId xmlns:a16="http://schemas.microsoft.com/office/drawing/2014/main" id="{B491C557-E6A7-804D-9274-518259E2CDCF}"/>
+                <a16:creationId xmlns:a16="http://schemas.microsoft.com/office/drawing/2014/main" id="{B52DDEEE-A2C6-6603-3B64-0F11D4E4A936}"/>
               </a:ext>
             </a:extLst>
           </p:cNvPr>
@@ -9297,8 +9991,8 @@
         </p:blipFill>
         <p:spPr bwMode="auto">
           <a:xfrm>
-            <a:off x="10842030" y="673147"/>
-            <a:ext cx="1171006" cy="1161019"/>
+            <a:off x="10953145" y="789591"/>
+            <a:ext cx="1053561" cy="1044575"/>
           </a:xfrm>
           <a:prstGeom prst="rect">
             <a:avLst/>
@@ -9320,7 +10014,7 @@
           <p:cNvPr id="4" name="Image 3">
             <a:extLst>
               <a:ext uri="{FF2B5EF4-FFF2-40B4-BE49-F238E27FC236}">
-                <a16:creationId xmlns:a16="http://schemas.microsoft.com/office/drawing/2014/main" id="{33CB2D14-BF59-8BB2-A94B-1955F7837AB1}"/>
+                <a16:creationId xmlns:a16="http://schemas.microsoft.com/office/drawing/2014/main" id="{CA1CA9A5-89E7-4365-AF94-B9A6B1CBD408}"/>
               </a:ext>
             </a:extLst>
           </p:cNvPr>
@@ -9337,8 +10031,8 @@
         </p:blipFill>
         <p:spPr>
           <a:xfrm>
-            <a:off x="526764" y="2967460"/>
-            <a:ext cx="3902623" cy="2484401"/>
+            <a:off x="1579119" y="2191554"/>
+            <a:ext cx="9374026" cy="4511250"/>
           </a:xfrm>
           <a:prstGeom prst="rect">
             <a:avLst/>
@@ -9347,10 +10041,10 @@
       </p:pic>
       <p:pic>
         <p:nvPicPr>
-          <p:cNvPr id="7" name="Image 6">
+          <p:cNvPr id="5" name="Image 4">
             <a:extLst>
               <a:ext uri="{FF2B5EF4-FFF2-40B4-BE49-F238E27FC236}">
-                <a16:creationId xmlns:a16="http://schemas.microsoft.com/office/drawing/2014/main" id="{19A4E7E0-DC1B-0D5F-3DB1-CB08A788C2E4}"/>
+                <a16:creationId xmlns:a16="http://schemas.microsoft.com/office/drawing/2014/main" id="{E8F69EBF-23E7-A7B2-F3A2-D7EC051799A0}"/>
               </a:ext>
             </a:extLst>
           </p:cNvPr>
@@ -9367,68 +10061,8 @@
         </p:blipFill>
         <p:spPr>
           <a:xfrm>
-            <a:off x="11269982" y="4000081"/>
-            <a:ext cx="743054" cy="419158"/>
-          </a:xfrm>
-          <a:prstGeom prst="rect">
-            <a:avLst/>
-          </a:prstGeom>
-        </p:spPr>
-      </p:pic>
-      <p:pic>
-        <p:nvPicPr>
-          <p:cNvPr id="9" name="Image 8">
-            <a:extLst>
-              <a:ext uri="{FF2B5EF4-FFF2-40B4-BE49-F238E27FC236}">
-                <a16:creationId xmlns:a16="http://schemas.microsoft.com/office/drawing/2014/main" id="{D2AF7216-5E29-A96F-9F65-6B0C08F05C3E}"/>
-              </a:ext>
-            </a:extLst>
-          </p:cNvPr>
-          <p:cNvPicPr>
-            <a:picLocks noChangeAspect="1"/>
-          </p:cNvPicPr>
-          <p:nvPr/>
-        </p:nvPicPr>
-        <p:blipFill>
-          <a:blip r:embed="rId5"/>
-          <a:stretch>
-            <a:fillRect/>
-          </a:stretch>
-        </p:blipFill>
-        <p:spPr>
-          <a:xfrm>
-            <a:off x="585487" y="2343486"/>
-            <a:ext cx="7430537" cy="409632"/>
-          </a:xfrm>
-          <a:prstGeom prst="rect">
-            <a:avLst/>
-          </a:prstGeom>
-        </p:spPr>
-      </p:pic>
-      <p:pic>
-        <p:nvPicPr>
-          <p:cNvPr id="11" name="Image 10">
-            <a:extLst>
-              <a:ext uri="{FF2B5EF4-FFF2-40B4-BE49-F238E27FC236}">
-                <a16:creationId xmlns:a16="http://schemas.microsoft.com/office/drawing/2014/main" id="{B710F0CD-B16C-6C43-B1AF-FF546CFB007A}"/>
-              </a:ext>
-            </a:extLst>
-          </p:cNvPr>
-          <p:cNvPicPr>
-            <a:picLocks noChangeAspect="1"/>
-          </p:cNvPicPr>
-          <p:nvPr/>
-        </p:nvPicPr>
-        <p:blipFill>
-          <a:blip r:embed="rId6"/>
-          <a:stretch>
-            <a:fillRect/>
-          </a:stretch>
-        </p:blipFill>
-        <p:spPr>
-          <a:xfrm>
-            <a:off x="4590875" y="3052859"/>
-            <a:ext cx="7506748" cy="419158"/>
+            <a:off x="4653555" y="2090707"/>
+            <a:ext cx="4357101" cy="4695987"/>
           </a:xfrm>
           <a:prstGeom prst="rect">
             <a:avLst/>
@@ -9438,7 +10072,7 @@
     </p:spTree>
     <p:extLst>
       <p:ext uri="{BB962C8B-B14F-4D97-AF65-F5344CB8AC3E}">
-        <p14:creationId xmlns:p14="http://schemas.microsoft.com/office/powerpoint/2010/main" val="1973557574"/>
+        <p14:creationId xmlns:p14="http://schemas.microsoft.com/office/powerpoint/2010/main" val="2410690974"/>
       </p:ext>
     </p:extLst>
   </p:cSld>
@@ -9545,7 +10179,7 @@
           <p:cNvPr id="4" name="Image 3">
             <a:extLst>
               <a:ext uri="{FF2B5EF4-FFF2-40B4-BE49-F238E27FC236}">
-                <a16:creationId xmlns:a16="http://schemas.microsoft.com/office/drawing/2014/main" id="{06BD1D5B-7A5F-36AB-7C5F-51B3EB2E8967}"/>
+                <a16:creationId xmlns:a16="http://schemas.microsoft.com/office/drawing/2014/main" id="{58C072AA-E7AD-7D7A-6DE3-806F10AD412A}"/>
               </a:ext>
             </a:extLst>
           </p:cNvPr>
@@ -9562,8 +10196,8 @@
         </p:blipFill>
         <p:spPr>
           <a:xfrm>
-            <a:off x="2452323" y="2182426"/>
-            <a:ext cx="6672288" cy="4478433"/>
+            <a:off x="1115735" y="2068876"/>
+            <a:ext cx="9764691" cy="4709429"/>
           </a:xfrm>
           <a:prstGeom prst="rect">
             <a:avLst/>
@@ -9573,7 +10207,7 @@
     </p:spTree>
     <p:extLst>
       <p:ext uri="{BB962C8B-B14F-4D97-AF65-F5344CB8AC3E}">
-        <p14:creationId xmlns:p14="http://schemas.microsoft.com/office/powerpoint/2010/main" val="1745120437"/>
+        <p14:creationId xmlns:p14="http://schemas.microsoft.com/office/powerpoint/2010/main" val="1000226763"/>
       </p:ext>
     </p:extLst>
   </p:cSld>
@@ -9605,7 +10239,7 @@
           <p:cNvPr id="2" name="Titre 1">
             <a:extLst>
               <a:ext uri="{FF2B5EF4-FFF2-40B4-BE49-F238E27FC236}">
-                <a16:creationId xmlns:a16="http://schemas.microsoft.com/office/drawing/2014/main" id="{F2D4B57F-2449-8012-12CC-ACCF428271E2}"/>
+                <a16:creationId xmlns:a16="http://schemas.microsoft.com/office/drawing/2014/main" id="{88173AE3-B121-232C-D4D9-F6BE4A2CCA13}"/>
               </a:ext>
             </a:extLst>
           </p:cNvPr>
@@ -9623,17 +10257,17 @@
           <a:p>
             <a:r>
               <a:rPr lang="fr-FR" dirty="0"/>
-              <a:t>Disponibilités JA</a:t>
+              <a:t>Juge Arbitre</a:t>
             </a:r>
           </a:p>
         </p:txBody>
       </p:sp>
       <p:pic>
         <p:nvPicPr>
-          <p:cNvPr id="3074" name="Picture 2" descr="Disponibilités JA">
+          <p:cNvPr id="2050" name="Picture 2" descr="Arbitre">
             <a:extLst>
               <a:ext uri="{FF2B5EF4-FFF2-40B4-BE49-F238E27FC236}">
-                <a16:creationId xmlns:a16="http://schemas.microsoft.com/office/drawing/2014/main" id="{11909562-16B8-3838-F899-1B87CA15D58F}"/>
+                <a16:creationId xmlns:a16="http://schemas.microsoft.com/office/drawing/2014/main" id="{B491C557-E6A7-804D-9274-518259E2CDCF}"/>
               </a:ext>
             </a:extLst>
           </p:cNvPr>
@@ -9657,8 +10291,8 @@
         </p:blipFill>
         <p:spPr bwMode="auto">
           <a:xfrm>
-            <a:off x="10893760" y="753228"/>
-            <a:ext cx="1092010" cy="1138420"/>
+            <a:off x="10842030" y="673147"/>
+            <a:ext cx="1171006" cy="1161019"/>
           </a:xfrm>
           <a:prstGeom prst="rect">
             <a:avLst/>
@@ -9677,10 +10311,10 @@
       </p:pic>
       <p:pic>
         <p:nvPicPr>
-          <p:cNvPr id="5" name="Image 4">
+          <p:cNvPr id="7" name="Image 6">
             <a:extLst>
               <a:ext uri="{FF2B5EF4-FFF2-40B4-BE49-F238E27FC236}">
-                <a16:creationId xmlns:a16="http://schemas.microsoft.com/office/drawing/2014/main" id="{CD294D9A-9F03-2365-0FFE-88B91C89129B}"/>
+                <a16:creationId xmlns:a16="http://schemas.microsoft.com/office/drawing/2014/main" id="{19A4E7E0-DC1B-0D5F-3DB1-CB08A788C2E4}"/>
               </a:ext>
             </a:extLst>
           </p:cNvPr>
@@ -9697,8 +10331,98 @@
         </p:blipFill>
         <p:spPr>
           <a:xfrm>
-            <a:off x="1493239" y="2069053"/>
-            <a:ext cx="9597051" cy="4608584"/>
+            <a:off x="6496646" y="4541757"/>
+            <a:ext cx="743054" cy="419158"/>
+          </a:xfrm>
+          <a:prstGeom prst="rect">
+            <a:avLst/>
+          </a:prstGeom>
+        </p:spPr>
+      </p:pic>
+      <p:pic>
+        <p:nvPicPr>
+          <p:cNvPr id="5" name="Image 4">
+            <a:extLst>
+              <a:ext uri="{FF2B5EF4-FFF2-40B4-BE49-F238E27FC236}">
+                <a16:creationId xmlns:a16="http://schemas.microsoft.com/office/drawing/2014/main" id="{7846E0A2-798B-EF82-AF15-3691912440DB}"/>
+              </a:ext>
+            </a:extLst>
+          </p:cNvPr>
+          <p:cNvPicPr>
+            <a:picLocks noChangeAspect="1"/>
+          </p:cNvPicPr>
+          <p:nvPr/>
+        </p:nvPicPr>
+        <p:blipFill>
+          <a:blip r:embed="rId4"/>
+          <a:stretch>
+            <a:fillRect/>
+          </a:stretch>
+        </p:blipFill>
+        <p:spPr>
+          <a:xfrm>
+            <a:off x="371254" y="3346695"/>
+            <a:ext cx="3781953" cy="2448267"/>
+          </a:xfrm>
+          <a:prstGeom prst="rect">
+            <a:avLst/>
+          </a:prstGeom>
+        </p:spPr>
+      </p:pic>
+      <p:pic>
+        <p:nvPicPr>
+          <p:cNvPr id="8" name="Image 7">
+            <a:extLst>
+              <a:ext uri="{FF2B5EF4-FFF2-40B4-BE49-F238E27FC236}">
+                <a16:creationId xmlns:a16="http://schemas.microsoft.com/office/drawing/2014/main" id="{A63ECFC0-62E6-A1A3-C035-619F7A43E716}"/>
+              </a:ext>
+            </a:extLst>
+          </p:cNvPr>
+          <p:cNvPicPr>
+            <a:picLocks noChangeAspect="1"/>
+          </p:cNvPicPr>
+          <p:nvPr/>
+        </p:nvPicPr>
+        <p:blipFill>
+          <a:blip r:embed="rId5"/>
+          <a:stretch>
+            <a:fillRect/>
+          </a:stretch>
+        </p:blipFill>
+        <p:spPr>
+          <a:xfrm>
+            <a:off x="4777466" y="3599975"/>
+            <a:ext cx="4029637" cy="400106"/>
+          </a:xfrm>
+          <a:prstGeom prst="rect">
+            <a:avLst/>
+          </a:prstGeom>
+        </p:spPr>
+      </p:pic>
+      <p:pic>
+        <p:nvPicPr>
+          <p:cNvPr id="12" name="Image 11">
+            <a:extLst>
+              <a:ext uri="{FF2B5EF4-FFF2-40B4-BE49-F238E27FC236}">
+                <a16:creationId xmlns:a16="http://schemas.microsoft.com/office/drawing/2014/main" id="{B17A73A6-8810-8CDE-31EB-184785ED1A0A}"/>
+              </a:ext>
+            </a:extLst>
+          </p:cNvPr>
+          <p:cNvPicPr>
+            <a:picLocks noChangeAspect="1"/>
+          </p:cNvPicPr>
+          <p:nvPr/>
+        </p:nvPicPr>
+        <p:blipFill>
+          <a:blip r:embed="rId6"/>
+          <a:stretch>
+            <a:fillRect/>
+          </a:stretch>
+        </p:blipFill>
+        <p:spPr>
+          <a:xfrm>
+            <a:off x="4029972" y="2620088"/>
+            <a:ext cx="7611537" cy="438211"/>
           </a:xfrm>
           <a:prstGeom prst="rect">
             <a:avLst/>
@@ -9708,7 +10432,7 @@
     </p:spTree>
     <p:extLst>
       <p:ext uri="{BB962C8B-B14F-4D97-AF65-F5344CB8AC3E}">
-        <p14:creationId xmlns:p14="http://schemas.microsoft.com/office/powerpoint/2010/main" val="1619598382"/>
+        <p14:creationId xmlns:p14="http://schemas.microsoft.com/office/powerpoint/2010/main" val="1973557574"/>
       </p:ext>
     </p:extLst>
   </p:cSld>
@@ -9740,7 +10464,7 @@
           <p:cNvPr id="2" name="Titre 1">
             <a:extLst>
               <a:ext uri="{FF2B5EF4-FFF2-40B4-BE49-F238E27FC236}">
-                <a16:creationId xmlns:a16="http://schemas.microsoft.com/office/drawing/2014/main" id="{F2D4B57F-2449-8012-12CC-ACCF428271E2}"/>
+                <a16:creationId xmlns:a16="http://schemas.microsoft.com/office/drawing/2014/main" id="{88173AE3-B121-232C-D4D9-F6BE4A2CCA13}"/>
               </a:ext>
             </a:extLst>
           </p:cNvPr>
@@ -9758,17 +10482,17 @@
           <a:p>
             <a:r>
               <a:rPr lang="fr-FR" dirty="0"/>
-              <a:t>Disponibilités JA</a:t>
+              <a:t>Juge Arbitre</a:t>
             </a:r>
           </a:p>
         </p:txBody>
       </p:sp>
       <p:pic>
         <p:nvPicPr>
-          <p:cNvPr id="3074" name="Picture 2" descr="Disponibilités JA">
+          <p:cNvPr id="2050" name="Picture 2" descr="Arbitre">
             <a:extLst>
               <a:ext uri="{FF2B5EF4-FFF2-40B4-BE49-F238E27FC236}">
-                <a16:creationId xmlns:a16="http://schemas.microsoft.com/office/drawing/2014/main" id="{11909562-16B8-3838-F899-1B87CA15D58F}"/>
+                <a16:creationId xmlns:a16="http://schemas.microsoft.com/office/drawing/2014/main" id="{B491C557-E6A7-804D-9274-518259E2CDCF}"/>
               </a:ext>
             </a:extLst>
           </p:cNvPr>
@@ -9792,8 +10516,8 @@
         </p:blipFill>
         <p:spPr bwMode="auto">
           <a:xfrm>
-            <a:off x="10893760" y="753228"/>
-            <a:ext cx="1092010" cy="1138420"/>
+            <a:off x="10842030" y="673147"/>
+            <a:ext cx="1171006" cy="1161019"/>
           </a:xfrm>
           <a:prstGeom prst="rect">
             <a:avLst/>
@@ -9812,10 +10536,10 @@
       </p:pic>
       <p:pic>
         <p:nvPicPr>
-          <p:cNvPr id="4" name="Image 3">
+          <p:cNvPr id="5" name="Image 4">
             <a:extLst>
               <a:ext uri="{FF2B5EF4-FFF2-40B4-BE49-F238E27FC236}">
-                <a16:creationId xmlns:a16="http://schemas.microsoft.com/office/drawing/2014/main" id="{7AB49EDF-1A92-E9B3-5985-87F0426F05F4}"/>
+                <a16:creationId xmlns:a16="http://schemas.microsoft.com/office/drawing/2014/main" id="{10596B0E-8137-557B-18C8-8E311322CBFB}"/>
               </a:ext>
             </a:extLst>
           </p:cNvPr>
@@ -9832,68 +10556,8 @@
         </p:blipFill>
         <p:spPr>
           <a:xfrm>
-            <a:off x="409223" y="2128956"/>
-            <a:ext cx="3760105" cy="3890044"/>
-          </a:xfrm>
-          <a:prstGeom prst="rect">
-            <a:avLst/>
-          </a:prstGeom>
-        </p:spPr>
-      </p:pic>
-      <p:pic>
-        <p:nvPicPr>
-          <p:cNvPr id="7" name="Image 6">
-            <a:extLst>
-              <a:ext uri="{FF2B5EF4-FFF2-40B4-BE49-F238E27FC236}">
-                <a16:creationId xmlns:a16="http://schemas.microsoft.com/office/drawing/2014/main" id="{22B64E45-33C1-2F45-A07D-746A0916CFE0}"/>
-              </a:ext>
-            </a:extLst>
-          </p:cNvPr>
-          <p:cNvPicPr>
-            <a:picLocks noChangeAspect="1"/>
-          </p:cNvPicPr>
-          <p:nvPr/>
-        </p:nvPicPr>
-        <p:blipFill>
-          <a:blip r:embed="rId4"/>
-          <a:stretch>
-            <a:fillRect/>
-          </a:stretch>
-        </p:blipFill>
-        <p:spPr>
-          <a:xfrm>
-            <a:off x="4908416" y="2304739"/>
-            <a:ext cx="6947277" cy="656575"/>
-          </a:xfrm>
-          <a:prstGeom prst="rect">
-            <a:avLst/>
-          </a:prstGeom>
-        </p:spPr>
-      </p:pic>
-      <p:pic>
-        <p:nvPicPr>
-          <p:cNvPr id="9" name="Image 8">
-            <a:extLst>
-              <a:ext uri="{FF2B5EF4-FFF2-40B4-BE49-F238E27FC236}">
-                <a16:creationId xmlns:a16="http://schemas.microsoft.com/office/drawing/2014/main" id="{74C3AE98-DC02-699A-355E-553CEB0E1D6F}"/>
-              </a:ext>
-            </a:extLst>
-          </p:cNvPr>
-          <p:cNvPicPr>
-            <a:picLocks noChangeAspect="1"/>
-          </p:cNvPicPr>
-          <p:nvPr/>
-        </p:nvPicPr>
-        <p:blipFill>
-          <a:blip r:embed="rId5"/>
-          <a:stretch>
-            <a:fillRect/>
-          </a:stretch>
-        </p:blipFill>
-        <p:spPr>
-          <a:xfrm>
-            <a:off x="7615563" y="3244133"/>
-            <a:ext cx="2229161" cy="1305107"/>
+            <a:off x="2057209" y="1754513"/>
+            <a:ext cx="7204237" cy="4820679"/>
           </a:xfrm>
           <a:prstGeom prst="rect">
             <a:avLst/>
@@ -9903,7 +10567,7 @@
     </p:spTree>
     <p:extLst>
       <p:ext uri="{BB962C8B-B14F-4D97-AF65-F5344CB8AC3E}">
-        <p14:creationId xmlns:p14="http://schemas.microsoft.com/office/powerpoint/2010/main" val="2361119301"/>
+        <p14:creationId xmlns:p14="http://schemas.microsoft.com/office/powerpoint/2010/main" val="1745120437"/>
       </p:ext>
     </p:extLst>
   </p:cSld>
@@ -10010,7 +10674,7 @@
           <p:cNvPr id="4" name="Image 3">
             <a:extLst>
               <a:ext uri="{FF2B5EF4-FFF2-40B4-BE49-F238E27FC236}">
-                <a16:creationId xmlns:a16="http://schemas.microsoft.com/office/drawing/2014/main" id="{223E5EB9-2120-73EA-3D13-359B9B673E99}"/>
+                <a16:creationId xmlns:a16="http://schemas.microsoft.com/office/drawing/2014/main" id="{74F137E4-91DF-0507-EC0F-439EBB0656B0}"/>
               </a:ext>
             </a:extLst>
           </p:cNvPr>
@@ -10027,8 +10691,8 @@
         </p:blipFill>
         <p:spPr>
           <a:xfrm>
-            <a:off x="1879133" y="2236680"/>
-            <a:ext cx="8899917" cy="4289955"/>
+            <a:off x="508234" y="1726352"/>
+            <a:ext cx="10271620" cy="4959082"/>
           </a:xfrm>
           <a:prstGeom prst="rect">
             <a:avLst/>
@@ -10038,7 +10702,7 @@
     </p:spTree>
     <p:extLst>
       <p:ext uri="{BB962C8B-B14F-4D97-AF65-F5344CB8AC3E}">
-        <p14:creationId xmlns:p14="http://schemas.microsoft.com/office/powerpoint/2010/main" val="1178459475"/>
+        <p14:creationId xmlns:p14="http://schemas.microsoft.com/office/powerpoint/2010/main" val="1619598382"/>
       </p:ext>
     </p:extLst>
   </p:cSld>

</xml_diff>